<commit_message>
Fix perfil offline y agregar presentacion de video
Corrige mvn test -Poffline cuando grpc.port queda vacio, lazy-init del cliente gRPC en karate-config, presentacion de 12 slides para el video y actualizacion del indice de entrega con Yamileidy Monne Clemente.

Co-authored-by: Cursor <cursoragent@cursor.com>
</commit_message>
<xml_diff>
--- a/docs/Presentacion_Reto_USSD_QA.pptx
+++ b/docs/Presentacion_Reto_USSD_QA.pptx
@@ -2,7 +2,7 @@
 <file path=ppt/presentation.xml><?xml version="1.0" encoding="utf-8"?>
 <p:presentation xmlns:a="http://schemas.openxmlformats.org/drawingml/2006/main" xmlns:r="http://schemas.openxmlformats.org/officeDocument/2006/relationships" xmlns:p="http://schemas.openxmlformats.org/presentationml/2006/main" saveSubsetFonts="1">
   <p:sldMasterIdLst>
-    <p:sldMasterId id="2147483660" r:id="rId1"/>
+    <p:sldMasterId id="2147483677" r:id="rId1"/>
   </p:sldMasterIdLst>
   <p:sldIdLst>
     <p:sldId id="256" r:id="rId2"/>
@@ -317,7 +317,7 @@
           <a:bodyPr/>
           <a:lstStyle/>
           <a:p>
-            <a:fld id="{02EF32BA-0AE0-49BE-BA0B-A4D586862B90}" type="datetimeFigureOut">
+            <a:fld id="{21F8010B-9147-40A5-9526-94E72FC5C30C}" type="datetimeFigureOut">
               <a:rPr lang="es-PE" smtClean="0"/>
               <a:t>2/06/2026</a:t>
             </a:fld>
@@ -446,7 +446,7 @@
           <a:bodyPr/>
           <a:lstStyle/>
           <a:p>
-            <a:fld id="{0291FBE7-E79C-498D-95E9-4B32D95A4003}" type="slidenum">
+            <a:fld id="{93FF651E-433E-43D7-A1EE-3D10A98E1E93}" type="slidenum">
               <a:rPr lang="es-PE" smtClean="0"/>
               <a:t>‹Nº›</a:t>
             </a:fld>
@@ -457,7 +457,7 @@
     </p:spTree>
     <p:extLst>
       <p:ext uri="{BB962C8B-B14F-4D97-AF65-F5344CB8AC3E}">
-        <p14:creationId xmlns:p14="http://schemas.microsoft.com/office/powerpoint/2010/main" val="3125534462"/>
+        <p14:creationId xmlns:p14="http://schemas.microsoft.com/office/powerpoint/2010/main" val="3246755644"/>
       </p:ext>
     </p:extLst>
   </p:cSld>
@@ -655,7 +655,7 @@
           <a:bodyPr/>
           <a:lstStyle/>
           <a:p>
-            <a:fld id="{02EF32BA-0AE0-49BE-BA0B-A4D586862B90}" type="datetimeFigureOut">
+            <a:fld id="{21F8010B-9147-40A5-9526-94E72FC5C30C}" type="datetimeFigureOut">
               <a:rPr lang="es-PE" smtClean="0"/>
               <a:t>2/06/2026</a:t>
             </a:fld>
@@ -784,7 +784,7 @@
           <a:bodyPr/>
           <a:lstStyle/>
           <a:p>
-            <a:fld id="{0291FBE7-E79C-498D-95E9-4B32D95A4003}" type="slidenum">
+            <a:fld id="{93FF651E-433E-43D7-A1EE-3D10A98E1E93}" type="slidenum">
               <a:rPr lang="es-PE" smtClean="0"/>
               <a:t>‹Nº›</a:t>
             </a:fld>
@@ -795,7 +795,7 @@
     </p:spTree>
     <p:extLst>
       <p:ext uri="{BB962C8B-B14F-4D97-AF65-F5344CB8AC3E}">
-        <p14:creationId xmlns:p14="http://schemas.microsoft.com/office/powerpoint/2010/main" val="2577947808"/>
+        <p14:creationId xmlns:p14="http://schemas.microsoft.com/office/powerpoint/2010/main" val="495235130"/>
       </p:ext>
     </p:extLst>
   </p:cSld>
@@ -1056,7 +1056,7 @@
           <a:bodyPr/>
           <a:lstStyle/>
           <a:p>
-            <a:fld id="{02EF32BA-0AE0-49BE-BA0B-A4D586862B90}" type="datetimeFigureOut">
+            <a:fld id="{21F8010B-9147-40A5-9526-94E72FC5C30C}" type="datetimeFigureOut">
               <a:rPr lang="es-PE" smtClean="0"/>
               <a:t>2/06/2026</a:t>
             </a:fld>
@@ -1185,7 +1185,7 @@
           <a:bodyPr/>
           <a:lstStyle/>
           <a:p>
-            <a:fld id="{0291FBE7-E79C-498D-95E9-4B32D95A4003}" type="slidenum">
+            <a:fld id="{93FF651E-433E-43D7-A1EE-3D10A98E1E93}" type="slidenum">
               <a:rPr lang="es-PE" smtClean="0"/>
               <a:t>‹Nº›</a:t>
             </a:fld>
@@ -1272,7 +1272,7 @@
     </p:spTree>
     <p:extLst>
       <p:ext uri="{BB962C8B-B14F-4D97-AF65-F5344CB8AC3E}">
-        <p14:creationId xmlns:p14="http://schemas.microsoft.com/office/powerpoint/2010/main" val="2384576549"/>
+        <p14:creationId xmlns:p14="http://schemas.microsoft.com/office/powerpoint/2010/main" val="3833298109"/>
       </p:ext>
     </p:extLst>
   </p:cSld>
@@ -1392,7 +1392,7 @@
           <a:bodyPr/>
           <a:lstStyle/>
           <a:p>
-            <a:fld id="{02EF32BA-0AE0-49BE-BA0B-A4D586862B90}" type="datetimeFigureOut">
+            <a:fld id="{21F8010B-9147-40A5-9526-94E72FC5C30C}" type="datetimeFigureOut">
               <a:rPr lang="es-PE" smtClean="0"/>
               <a:t>2/06/2026</a:t>
             </a:fld>
@@ -1521,7 +1521,7 @@
           <a:bodyPr/>
           <a:lstStyle/>
           <a:p>
-            <a:fld id="{0291FBE7-E79C-498D-95E9-4B32D95A4003}" type="slidenum">
+            <a:fld id="{93FF651E-433E-43D7-A1EE-3D10A98E1E93}" type="slidenum">
               <a:rPr lang="es-PE" smtClean="0"/>
               <a:t>‹Nº›</a:t>
             </a:fld>
@@ -1532,7 +1532,7 @@
     </p:spTree>
     <p:extLst>
       <p:ext uri="{BB962C8B-B14F-4D97-AF65-F5344CB8AC3E}">
-        <p14:creationId xmlns:p14="http://schemas.microsoft.com/office/powerpoint/2010/main" val="3952486779"/>
+        <p14:creationId xmlns:p14="http://schemas.microsoft.com/office/powerpoint/2010/main" val="1059216743"/>
       </p:ext>
     </p:extLst>
   </p:cSld>
@@ -1712,7 +1712,7 @@
           <a:bodyPr/>
           <a:lstStyle/>
           <a:p>
-            <a:fld id="{02EF32BA-0AE0-49BE-BA0B-A4D586862B90}" type="datetimeFigureOut">
+            <a:fld id="{21F8010B-9147-40A5-9526-94E72FC5C30C}" type="datetimeFigureOut">
               <a:rPr lang="es-PE" smtClean="0"/>
               <a:t>2/06/2026</a:t>
             </a:fld>
@@ -1841,7 +1841,7 @@
           <a:bodyPr/>
           <a:lstStyle/>
           <a:p>
-            <a:fld id="{0291FBE7-E79C-498D-95E9-4B32D95A4003}" type="slidenum">
+            <a:fld id="{93FF651E-433E-43D7-A1EE-3D10A98E1E93}" type="slidenum">
               <a:rPr lang="es-PE" smtClean="0"/>
               <a:t>‹Nº›</a:t>
             </a:fld>
@@ -1928,7 +1928,7 @@
     </p:spTree>
     <p:extLst>
       <p:ext uri="{BB962C8B-B14F-4D97-AF65-F5344CB8AC3E}">
-        <p14:creationId xmlns:p14="http://schemas.microsoft.com/office/powerpoint/2010/main" val="2828615576"/>
+        <p14:creationId xmlns:p14="http://schemas.microsoft.com/office/powerpoint/2010/main" val="995651544"/>
       </p:ext>
     </p:extLst>
   </p:cSld>
@@ -2108,7 +2108,7 @@
           <a:bodyPr/>
           <a:lstStyle/>
           <a:p>
-            <a:fld id="{02EF32BA-0AE0-49BE-BA0B-A4D586862B90}" type="datetimeFigureOut">
+            <a:fld id="{21F8010B-9147-40A5-9526-94E72FC5C30C}" type="datetimeFigureOut">
               <a:rPr lang="es-PE" smtClean="0"/>
               <a:t>2/06/2026</a:t>
             </a:fld>
@@ -2237,7 +2237,7 @@
           <a:bodyPr/>
           <a:lstStyle/>
           <a:p>
-            <a:fld id="{0291FBE7-E79C-498D-95E9-4B32D95A4003}" type="slidenum">
+            <a:fld id="{93FF651E-433E-43D7-A1EE-3D10A98E1E93}" type="slidenum">
               <a:rPr lang="es-PE" smtClean="0"/>
               <a:t>‹Nº›</a:t>
             </a:fld>
@@ -2248,7 +2248,7 @@
     </p:spTree>
     <p:extLst>
       <p:ext uri="{BB962C8B-B14F-4D97-AF65-F5344CB8AC3E}">
-        <p14:creationId xmlns:p14="http://schemas.microsoft.com/office/powerpoint/2010/main" val="2951180446"/>
+        <p14:creationId xmlns:p14="http://schemas.microsoft.com/office/powerpoint/2010/main" val="2989442609"/>
       </p:ext>
     </p:extLst>
   </p:cSld>
@@ -2365,7 +2365,7 @@
           <a:bodyPr/>
           <a:lstStyle/>
           <a:p>
-            <a:fld id="{02EF32BA-0AE0-49BE-BA0B-A4D586862B90}" type="datetimeFigureOut">
+            <a:fld id="{21F8010B-9147-40A5-9526-94E72FC5C30C}" type="datetimeFigureOut">
               <a:rPr lang="es-PE" smtClean="0"/>
               <a:t>2/06/2026</a:t>
             </a:fld>
@@ -2489,7 +2489,7 @@
           <a:bodyPr/>
           <a:lstStyle/>
           <a:p>
-            <a:fld id="{0291FBE7-E79C-498D-95E9-4B32D95A4003}" type="slidenum">
+            <a:fld id="{93FF651E-433E-43D7-A1EE-3D10A98E1E93}" type="slidenum">
               <a:rPr lang="es-PE" smtClean="0"/>
               <a:t>‹Nº›</a:t>
             </a:fld>
@@ -2500,7 +2500,7 @@
     </p:spTree>
     <p:extLst>
       <p:ext uri="{BB962C8B-B14F-4D97-AF65-F5344CB8AC3E}">
-        <p14:creationId xmlns:p14="http://schemas.microsoft.com/office/powerpoint/2010/main" val="3949721496"/>
+        <p14:creationId xmlns:p14="http://schemas.microsoft.com/office/powerpoint/2010/main" val="3710115296"/>
       </p:ext>
     </p:extLst>
   </p:cSld>
@@ -2627,7 +2627,7 @@
           <a:bodyPr/>
           <a:lstStyle/>
           <a:p>
-            <a:fld id="{02EF32BA-0AE0-49BE-BA0B-A4D586862B90}" type="datetimeFigureOut">
+            <a:fld id="{21F8010B-9147-40A5-9526-94E72FC5C30C}" type="datetimeFigureOut">
               <a:rPr lang="es-PE" smtClean="0"/>
               <a:t>2/06/2026</a:t>
             </a:fld>
@@ -2751,7 +2751,7 @@
           <a:bodyPr/>
           <a:lstStyle/>
           <a:p>
-            <a:fld id="{0291FBE7-E79C-498D-95E9-4B32D95A4003}" type="slidenum">
+            <a:fld id="{93FF651E-433E-43D7-A1EE-3D10A98E1E93}" type="slidenum">
               <a:rPr lang="es-PE" smtClean="0"/>
               <a:t>‹Nº›</a:t>
             </a:fld>
@@ -2762,7 +2762,7 @@
     </p:spTree>
     <p:extLst>
       <p:ext uri="{BB962C8B-B14F-4D97-AF65-F5344CB8AC3E}">
-        <p14:creationId xmlns:p14="http://schemas.microsoft.com/office/powerpoint/2010/main" val="3766816597"/>
+        <p14:creationId xmlns:p14="http://schemas.microsoft.com/office/powerpoint/2010/main" val="1227981171"/>
       </p:ext>
     </p:extLst>
   </p:cSld>
@@ -2889,7 +2889,7 @@
           <a:bodyPr/>
           <a:lstStyle/>
           <a:p>
-            <a:fld id="{02EF32BA-0AE0-49BE-BA0B-A4D586862B90}" type="datetimeFigureOut">
+            <a:fld id="{21F8010B-9147-40A5-9526-94E72FC5C30C}" type="datetimeFigureOut">
               <a:rPr lang="es-PE" smtClean="0"/>
               <a:t>2/06/2026</a:t>
             </a:fld>
@@ -3013,7 +3013,7 @@
           <a:bodyPr/>
           <a:lstStyle/>
           <a:p>
-            <a:fld id="{0291FBE7-E79C-498D-95E9-4B32D95A4003}" type="slidenum">
+            <a:fld id="{93FF651E-433E-43D7-A1EE-3D10A98E1E93}" type="slidenum">
               <a:rPr lang="es-PE" smtClean="0"/>
               <a:t>‹Nº›</a:t>
             </a:fld>
@@ -3024,7 +3024,7 @@
     </p:spTree>
     <p:extLst>
       <p:ext uri="{BB962C8B-B14F-4D97-AF65-F5344CB8AC3E}">
-        <p14:creationId xmlns:p14="http://schemas.microsoft.com/office/powerpoint/2010/main" val="1264823441"/>
+        <p14:creationId xmlns:p14="http://schemas.microsoft.com/office/powerpoint/2010/main" val="805782069"/>
       </p:ext>
     </p:extLst>
   </p:cSld>
@@ -3218,7 +3218,7 @@
           <a:bodyPr/>
           <a:lstStyle/>
           <a:p>
-            <a:fld id="{02EF32BA-0AE0-49BE-BA0B-A4D586862B90}" type="datetimeFigureOut">
+            <a:fld id="{21F8010B-9147-40A5-9526-94E72FC5C30C}" type="datetimeFigureOut">
               <a:rPr lang="es-PE" smtClean="0"/>
               <a:t>2/06/2026</a:t>
             </a:fld>
@@ -3347,7 +3347,7 @@
           <a:bodyPr/>
           <a:lstStyle/>
           <a:p>
-            <a:fld id="{0291FBE7-E79C-498D-95E9-4B32D95A4003}" type="slidenum">
+            <a:fld id="{93FF651E-433E-43D7-A1EE-3D10A98E1E93}" type="slidenum">
               <a:rPr lang="es-PE" smtClean="0"/>
               <a:t>‹Nº›</a:t>
             </a:fld>
@@ -3358,7 +3358,7 @@
     </p:spTree>
     <p:extLst>
       <p:ext uri="{BB962C8B-B14F-4D97-AF65-F5344CB8AC3E}">
-        <p14:creationId xmlns:p14="http://schemas.microsoft.com/office/powerpoint/2010/main" val="695948002"/>
+        <p14:creationId xmlns:p14="http://schemas.microsoft.com/office/powerpoint/2010/main" val="423424479"/>
       </p:ext>
     </p:extLst>
   </p:cSld>
@@ -3541,7 +3541,7 @@
           <a:bodyPr/>
           <a:lstStyle/>
           <a:p>
-            <a:fld id="{02EF32BA-0AE0-49BE-BA0B-A4D586862B90}" type="datetimeFigureOut">
+            <a:fld id="{21F8010B-9147-40A5-9526-94E72FC5C30C}" type="datetimeFigureOut">
               <a:rPr lang="es-PE" smtClean="0"/>
               <a:t>2/06/2026</a:t>
             </a:fld>
@@ -3670,7 +3670,7 @@
           <a:bodyPr/>
           <a:lstStyle/>
           <a:p>
-            <a:fld id="{0291FBE7-E79C-498D-95E9-4B32D95A4003}" type="slidenum">
+            <a:fld id="{93FF651E-433E-43D7-A1EE-3D10A98E1E93}" type="slidenum">
               <a:rPr lang="es-PE" smtClean="0"/>
               <a:t>‹Nº›</a:t>
             </a:fld>
@@ -3681,7 +3681,7 @@
     </p:spTree>
     <p:extLst>
       <p:ext uri="{BB962C8B-B14F-4D97-AF65-F5344CB8AC3E}">
-        <p14:creationId xmlns:p14="http://schemas.microsoft.com/office/powerpoint/2010/main" val="167501679"/>
+        <p14:creationId xmlns:p14="http://schemas.microsoft.com/office/powerpoint/2010/main" val="3480176159"/>
       </p:ext>
     </p:extLst>
   </p:cSld>
@@ -3998,7 +3998,7 @@
           <a:bodyPr/>
           <a:lstStyle/>
           <a:p>
-            <a:fld id="{02EF32BA-0AE0-49BE-BA0B-A4D586862B90}" type="datetimeFigureOut">
+            <a:fld id="{21F8010B-9147-40A5-9526-94E72FC5C30C}" type="datetimeFigureOut">
               <a:rPr lang="es-PE" smtClean="0"/>
               <a:t>2/06/2026</a:t>
             </a:fld>
@@ -4127,7 +4127,7 @@
           <a:bodyPr/>
           <a:lstStyle/>
           <a:p>
-            <a:fld id="{0291FBE7-E79C-498D-95E9-4B32D95A4003}" type="slidenum">
+            <a:fld id="{93FF651E-433E-43D7-A1EE-3D10A98E1E93}" type="slidenum">
               <a:rPr lang="es-PE" smtClean="0"/>
               <a:t>‹Nº›</a:t>
             </a:fld>
@@ -4138,7 +4138,7 @@
     </p:spTree>
     <p:extLst>
       <p:ext uri="{BB962C8B-B14F-4D97-AF65-F5344CB8AC3E}">
-        <p14:creationId xmlns:p14="http://schemas.microsoft.com/office/powerpoint/2010/main" val="4071601766"/>
+        <p14:creationId xmlns:p14="http://schemas.microsoft.com/office/powerpoint/2010/main" val="3101680467"/>
       </p:ext>
     </p:extLst>
   </p:cSld>
@@ -4203,7 +4203,7 @@
           <a:bodyPr/>
           <a:lstStyle/>
           <a:p>
-            <a:fld id="{02EF32BA-0AE0-49BE-BA0B-A4D586862B90}" type="datetimeFigureOut">
+            <a:fld id="{21F8010B-9147-40A5-9526-94E72FC5C30C}" type="datetimeFigureOut">
               <a:rPr lang="es-PE" smtClean="0"/>
               <a:t>2/06/2026</a:t>
             </a:fld>
@@ -4327,7 +4327,7 @@
           <a:bodyPr/>
           <a:lstStyle/>
           <a:p>
-            <a:fld id="{0291FBE7-E79C-498D-95E9-4B32D95A4003}" type="slidenum">
+            <a:fld id="{93FF651E-433E-43D7-A1EE-3D10A98E1E93}" type="slidenum">
               <a:rPr lang="es-PE" smtClean="0"/>
               <a:t>‹Nº›</a:t>
             </a:fld>
@@ -4338,7 +4338,7 @@
     </p:spTree>
     <p:extLst>
       <p:ext uri="{BB962C8B-B14F-4D97-AF65-F5344CB8AC3E}">
-        <p14:creationId xmlns:p14="http://schemas.microsoft.com/office/powerpoint/2010/main" val="111293797"/>
+        <p14:creationId xmlns:p14="http://schemas.microsoft.com/office/powerpoint/2010/main" val="2767581840"/>
       </p:ext>
     </p:extLst>
   </p:cSld>
@@ -4380,7 +4380,7 @@
           <a:bodyPr/>
           <a:lstStyle/>
           <a:p>
-            <a:fld id="{02EF32BA-0AE0-49BE-BA0B-A4D586862B90}" type="datetimeFigureOut">
+            <a:fld id="{21F8010B-9147-40A5-9526-94E72FC5C30C}" type="datetimeFigureOut">
               <a:rPr lang="es-PE" smtClean="0"/>
               <a:t>2/06/2026</a:t>
             </a:fld>
@@ -4504,7 +4504,7 @@
           <a:bodyPr/>
           <a:lstStyle/>
           <a:p>
-            <a:fld id="{0291FBE7-E79C-498D-95E9-4B32D95A4003}" type="slidenum">
+            <a:fld id="{93FF651E-433E-43D7-A1EE-3D10A98E1E93}" type="slidenum">
               <a:rPr lang="es-PE" smtClean="0"/>
               <a:t>‹Nº›</a:t>
             </a:fld>
@@ -4515,7 +4515,7 @@
     </p:spTree>
     <p:extLst>
       <p:ext uri="{BB962C8B-B14F-4D97-AF65-F5344CB8AC3E}">
-        <p14:creationId xmlns:p14="http://schemas.microsoft.com/office/powerpoint/2010/main" val="1620508859"/>
+        <p14:creationId xmlns:p14="http://schemas.microsoft.com/office/powerpoint/2010/main" val="2552003265"/>
       </p:ext>
     </p:extLst>
   </p:cSld>
@@ -4713,7 +4713,7 @@
           <a:bodyPr/>
           <a:lstStyle/>
           <a:p>
-            <a:fld id="{02EF32BA-0AE0-49BE-BA0B-A4D586862B90}" type="datetimeFigureOut">
+            <a:fld id="{21F8010B-9147-40A5-9526-94E72FC5C30C}" type="datetimeFigureOut">
               <a:rPr lang="es-PE" smtClean="0"/>
               <a:t>2/06/2026</a:t>
             </a:fld>
@@ -4837,7 +4837,7 @@
           <a:bodyPr/>
           <a:lstStyle/>
           <a:p>
-            <a:fld id="{0291FBE7-E79C-498D-95E9-4B32D95A4003}" type="slidenum">
+            <a:fld id="{93FF651E-433E-43D7-A1EE-3D10A98E1E93}" type="slidenum">
               <a:rPr lang="es-PE" smtClean="0"/>
               <a:t>‹Nº›</a:t>
             </a:fld>
@@ -4848,7 +4848,7 @@
     </p:spTree>
     <p:extLst>
       <p:ext uri="{BB962C8B-B14F-4D97-AF65-F5344CB8AC3E}">
-        <p14:creationId xmlns:p14="http://schemas.microsoft.com/office/powerpoint/2010/main" val="3617325101"/>
+        <p14:creationId xmlns:p14="http://schemas.microsoft.com/office/powerpoint/2010/main" val="1155348510"/>
       </p:ext>
     </p:extLst>
   </p:cSld>
@@ -5058,7 +5058,7 @@
           <a:bodyPr/>
           <a:lstStyle/>
           <a:p>
-            <a:fld id="{02EF32BA-0AE0-49BE-BA0B-A4D586862B90}" type="datetimeFigureOut">
+            <a:fld id="{21F8010B-9147-40A5-9526-94E72FC5C30C}" type="datetimeFigureOut">
               <a:rPr lang="es-PE" smtClean="0"/>
               <a:t>2/06/2026</a:t>
             </a:fld>
@@ -5187,7 +5187,7 @@
           <a:bodyPr/>
           <a:lstStyle/>
           <a:p>
-            <a:fld id="{0291FBE7-E79C-498D-95E9-4B32D95A4003}" type="slidenum">
+            <a:fld id="{93FF651E-433E-43D7-A1EE-3D10A98E1E93}" type="slidenum">
               <a:rPr lang="es-PE" smtClean="0"/>
               <a:t>‹Nº›</a:t>
             </a:fld>
@@ -5198,7 +5198,7 @@
     </p:spTree>
     <p:extLst>
       <p:ext uri="{BB962C8B-B14F-4D97-AF65-F5344CB8AC3E}">
-        <p14:creationId xmlns:p14="http://schemas.microsoft.com/office/powerpoint/2010/main" val="2490356351"/>
+        <p14:creationId xmlns:p14="http://schemas.microsoft.com/office/powerpoint/2010/main" val="1488572615"/>
       </p:ext>
     </p:extLst>
   </p:cSld>
@@ -7175,7 +7175,7 @@
             </a:lvl1pPr>
           </a:lstStyle>
           <a:p>
-            <a:fld id="{02EF32BA-0AE0-49BE-BA0B-A4D586862B90}" type="datetimeFigureOut">
+            <a:fld id="{21F8010B-9147-40A5-9526-94E72FC5C30C}" type="datetimeFigureOut">
               <a:rPr lang="es-PE" smtClean="0"/>
               <a:t>2/06/2026</a:t>
             </a:fld>
@@ -7251,7 +7251,7 @@
             </a:lvl1pPr>
           </a:lstStyle>
           <a:p>
-            <a:fld id="{0291FBE7-E79C-498D-95E9-4B32D95A4003}" type="slidenum">
+            <a:fld id="{93FF651E-433E-43D7-A1EE-3D10A98E1E93}" type="slidenum">
               <a:rPr lang="es-PE" smtClean="0"/>
               <a:t>‹Nº›</a:t>
             </a:fld>
@@ -7262,28 +7262,28 @@
     </p:spTree>
     <p:extLst>
       <p:ext uri="{BB962C8B-B14F-4D97-AF65-F5344CB8AC3E}">
-        <p14:creationId xmlns:p14="http://schemas.microsoft.com/office/powerpoint/2010/main" val="4276050283"/>
+        <p14:creationId xmlns:p14="http://schemas.microsoft.com/office/powerpoint/2010/main" val="3927938788"/>
       </p:ext>
     </p:extLst>
   </p:cSld>
   <p:clrMap bg1="lt1" tx1="dk1" bg2="lt2" tx2="dk2" accent1="accent1" accent2="accent2" accent3="accent3" accent4="accent4" accent5="accent5" accent6="accent6" hlink="hlink" folHlink="folHlink"/>
   <p:sldLayoutIdLst>
-    <p:sldLayoutId id="2147483661" r:id="rId1"/>
-    <p:sldLayoutId id="2147483662" r:id="rId2"/>
-    <p:sldLayoutId id="2147483663" r:id="rId3"/>
-    <p:sldLayoutId id="2147483664" r:id="rId4"/>
-    <p:sldLayoutId id="2147483665" r:id="rId5"/>
-    <p:sldLayoutId id="2147483666" r:id="rId6"/>
-    <p:sldLayoutId id="2147483667" r:id="rId7"/>
-    <p:sldLayoutId id="2147483668" r:id="rId8"/>
-    <p:sldLayoutId id="2147483669" r:id="rId9"/>
-    <p:sldLayoutId id="2147483670" r:id="rId10"/>
-    <p:sldLayoutId id="2147483671" r:id="rId11"/>
-    <p:sldLayoutId id="2147483672" r:id="rId12"/>
-    <p:sldLayoutId id="2147483673" r:id="rId13"/>
-    <p:sldLayoutId id="2147483674" r:id="rId14"/>
-    <p:sldLayoutId id="2147483675" r:id="rId15"/>
-    <p:sldLayoutId id="2147483676" r:id="rId16"/>
+    <p:sldLayoutId id="2147483678" r:id="rId1"/>
+    <p:sldLayoutId id="2147483679" r:id="rId2"/>
+    <p:sldLayoutId id="2147483680" r:id="rId3"/>
+    <p:sldLayoutId id="2147483681" r:id="rId4"/>
+    <p:sldLayoutId id="2147483682" r:id="rId5"/>
+    <p:sldLayoutId id="2147483683" r:id="rId6"/>
+    <p:sldLayoutId id="2147483684" r:id="rId7"/>
+    <p:sldLayoutId id="2147483685" r:id="rId8"/>
+    <p:sldLayoutId id="2147483686" r:id="rId9"/>
+    <p:sldLayoutId id="2147483687" r:id="rId10"/>
+    <p:sldLayoutId id="2147483688" r:id="rId11"/>
+    <p:sldLayoutId id="2147483689" r:id="rId12"/>
+    <p:sldLayoutId id="2147483690" r:id="rId13"/>
+    <p:sldLayoutId id="2147483691" r:id="rId14"/>
+    <p:sldLayoutId id="2147483692" r:id="rId15"/>
+    <p:sldLayoutId id="2147483693" r:id="rId16"/>
   </p:sldLayoutIdLst>
   <p:txStyles>
     <p:titleStyle>
@@ -7700,7 +7700,7 @@
           <p:cNvPr id="2" name="Título 1">
             <a:extLst>
               <a:ext uri="{FF2B5EF4-FFF2-40B4-BE49-F238E27FC236}">
-                <a16:creationId xmlns:a16="http://schemas.microsoft.com/office/drawing/2014/main" id="{1CF2CC19-4AD3-E737-D8EA-9FF7C36A8C97}"/>
+                <a16:creationId xmlns:a16="http://schemas.microsoft.com/office/drawing/2014/main" id="{D36CD68D-844B-DC81-DB22-67C576EDD3D0}"/>
               </a:ext>
             </a:extLst>
           </p:cNvPr>
@@ -7717,7 +7717,7 @@
           <a:lstStyle/>
           <a:p>
             <a:r>
-              <a:rPr lang="es-PE" dirty="0"/>
+              <a:rPr lang="es-PE"/>
               <a:t>Aseguramiento de Calidad</a:t>
             </a:r>
           </a:p>
@@ -7728,7 +7728,7 @@
           <p:cNvPr id="3" name="Subtítulo 2">
             <a:extLst>
               <a:ext uri="{FF2B5EF4-FFF2-40B4-BE49-F238E27FC236}">
-                <a16:creationId xmlns:a16="http://schemas.microsoft.com/office/drawing/2014/main" id="{7D941301-805D-8F96-EDC6-2CB17F65FB8D}"/>
+                <a16:creationId xmlns:a16="http://schemas.microsoft.com/office/drawing/2014/main" id="{2EE3BD6A-7B9B-8B75-1531-7AFCF276B267}"/>
               </a:ext>
             </a:extLst>
           </p:cNvPr>
@@ -7741,37 +7741,13 @@
         </p:nvSpPr>
         <p:spPr/>
         <p:txBody>
-          <a:bodyPr>
-            <a:normAutofit lnSpcReduction="10000"/>
-          </a:bodyPr>
-          <a:lstStyle/>
-          <a:p>
-            <a:r>
-              <a:rPr lang="es-PE" dirty="0"/>
-              <a:t>Plataforma USSD (</a:t>
-            </a:r>
-            <a:r>
-              <a:rPr lang="es-PE" dirty="0" err="1"/>
-              <a:t>gRPC</a:t>
-            </a:r>
-            <a:r>
-              <a:rPr lang="es-PE" dirty="0"/>
-              <a:t>) - Reto </a:t>
-            </a:r>
-            <a:r>
-              <a:rPr lang="es-PE" dirty="0" err="1"/>
-              <a:t>Hakom</a:t>
-            </a:r>
-            <a:r>
-              <a:rPr lang="es-PE" dirty="0"/>
-              <a:t>
-Karate + Java | Junio 2026</a:t>
-            </a:r>
-          </a:p>
-          <a:p>
-            <a:r>
-              <a:rPr lang="es-PE" dirty="0"/>
-              <a:t>Yamileidy Monne Clemente</a:t>
+          <a:bodyPr/>
+          <a:lstStyle/>
+          <a:p>
+            <a:r>
+              <a:rPr lang="es-PE"/>
+              <a:t>Plataforma USSD (gRPC) - Reto Hakom
+Yamileidy Monne Clemente | Karate + Java | Junio 2026</a:t>
             </a:r>
           </a:p>
         </p:txBody>
@@ -7779,7 +7755,7 @@
     </p:spTree>
     <p:extLst>
       <p:ext uri="{BB962C8B-B14F-4D97-AF65-F5344CB8AC3E}">
-        <p14:creationId xmlns:p14="http://schemas.microsoft.com/office/powerpoint/2010/main" val="725301402"/>
+        <p14:creationId xmlns:p14="http://schemas.microsoft.com/office/powerpoint/2010/main" val="835748618"/>
       </p:ext>
     </p:extLst>
   </p:cSld>
@@ -7811,7 +7787,7 @@
           <p:cNvPr id="2" name="Título 1">
             <a:extLst>
               <a:ext uri="{FF2B5EF4-FFF2-40B4-BE49-F238E27FC236}">
-                <a16:creationId xmlns:a16="http://schemas.microsoft.com/office/drawing/2014/main" id="{CDA82F66-477E-00A8-C13E-F90FDDC9F2CA}"/>
+                <a16:creationId xmlns:a16="http://schemas.microsoft.com/office/drawing/2014/main" id="{7E27CC40-E88E-C554-0292-6D18590695FF}"/>
               </a:ext>
             </a:extLst>
           </p:cNvPr>
@@ -7840,7 +7816,7 @@
           <p:cNvPr id="3" name="Marcador de contenido 2">
             <a:extLst>
               <a:ext uri="{FF2B5EF4-FFF2-40B4-BE49-F238E27FC236}">
-                <a16:creationId xmlns:a16="http://schemas.microsoft.com/office/drawing/2014/main" id="{99E56B6D-9037-12B9-3154-6A4B55692ECD}"/>
+                <a16:creationId xmlns:a16="http://schemas.microsoft.com/office/drawing/2014/main" id="{8C65B2B0-886F-A9CD-D82D-6D0EAFF3AB3F}"/>
               </a:ext>
             </a:extLst>
           </p:cNvPr>
@@ -7891,7 +7867,7 @@
     </p:spTree>
     <p:extLst>
       <p:ext uri="{BB962C8B-B14F-4D97-AF65-F5344CB8AC3E}">
-        <p14:creationId xmlns:p14="http://schemas.microsoft.com/office/powerpoint/2010/main" val="1233323493"/>
+        <p14:creationId xmlns:p14="http://schemas.microsoft.com/office/powerpoint/2010/main" val="1367359063"/>
       </p:ext>
     </p:extLst>
   </p:cSld>
@@ -7923,7 +7899,7 @@
           <p:cNvPr id="2" name="Título 1">
             <a:extLst>
               <a:ext uri="{FF2B5EF4-FFF2-40B4-BE49-F238E27FC236}">
-                <a16:creationId xmlns:a16="http://schemas.microsoft.com/office/drawing/2014/main" id="{B6056001-41F4-CD92-5284-7CA9EB62DA6C}"/>
+                <a16:creationId xmlns:a16="http://schemas.microsoft.com/office/drawing/2014/main" id="{1A3C0BF8-3E20-EBD4-1677-816DF59218E2}"/>
               </a:ext>
             </a:extLst>
           </p:cNvPr>
@@ -7951,7 +7927,7 @@
           <p:cNvPr id="3" name="Marcador de contenido 2">
             <a:extLst>
               <a:ext uri="{FF2B5EF4-FFF2-40B4-BE49-F238E27FC236}">
-                <a16:creationId xmlns:a16="http://schemas.microsoft.com/office/drawing/2014/main" id="{19EF44E2-AC54-59FC-F5A6-FD578C78CA4E}"/>
+                <a16:creationId xmlns:a16="http://schemas.microsoft.com/office/drawing/2014/main" id="{D24E67C3-3A11-2085-964A-298986C0829E}"/>
               </a:ext>
             </a:extLst>
           </p:cNvPr>
@@ -7968,39 +7944,35 @@
           <a:lstStyle/>
           <a:p>
             <a:r>
-              <a:rPr lang="es-ES" dirty="0"/>
-              <a:t>MSISDN = número de teléfono del cliente</a:t>
-            </a:r>
-          </a:p>
-          <a:p>
-            <a:r>
-              <a:rPr lang="es-ES" dirty="0"/>
-              <a:t>Si cambia en mitad de sesión: datos de otro usuario</a:t>
-            </a:r>
-          </a:p>
-          <a:p>
-            <a:r>
-              <a:rPr lang="es-ES" dirty="0"/>
-              <a:t>Impacto muy alto: regulación y reputación</a:t>
-            </a:r>
-          </a:p>
-          <a:p>
-            <a:r>
-              <a:rPr lang="es-ES" dirty="0"/>
-              <a:t>Control QA: validación en todos los flujos </a:t>
-            </a:r>
-            <a:r>
-              <a:rPr lang="es-ES" dirty="0" err="1"/>
-              <a:t>grpc</a:t>
-            </a:r>
-            <a:endParaRPr lang="es-PE" dirty="0"/>
+              <a:rPr lang="es-ES"/>
+              <a:t>MSISDN = numero de telefono del cliente</a:t>
+            </a:r>
+          </a:p>
+          <a:p>
+            <a:r>
+              <a:rPr lang="es-ES"/>
+              <a:t>Si cambia en mitad de sesion: datos de otro usuario</a:t>
+            </a:r>
+          </a:p>
+          <a:p>
+            <a:r>
+              <a:rPr lang="es-ES"/>
+              <a:t>Impacto muy alto: regulacion y reputacion</a:t>
+            </a:r>
+          </a:p>
+          <a:p>
+            <a:r>
+              <a:rPr lang="es-ES"/>
+              <a:t>Control QA: validacion en todos los flujos grpc</a:t>
+            </a:r>
+            <a:endParaRPr lang="es-PE"/>
           </a:p>
         </p:txBody>
       </p:sp>
     </p:spTree>
     <p:extLst>
       <p:ext uri="{BB962C8B-B14F-4D97-AF65-F5344CB8AC3E}">
-        <p14:creationId xmlns:p14="http://schemas.microsoft.com/office/powerpoint/2010/main" val="3433715059"/>
+        <p14:creationId xmlns:p14="http://schemas.microsoft.com/office/powerpoint/2010/main" val="2478023907"/>
       </p:ext>
     </p:extLst>
   </p:cSld>
@@ -8032,7 +8004,7 @@
           <p:cNvPr id="2" name="Título 1">
             <a:extLst>
               <a:ext uri="{FF2B5EF4-FFF2-40B4-BE49-F238E27FC236}">
-                <a16:creationId xmlns:a16="http://schemas.microsoft.com/office/drawing/2014/main" id="{D7FF15D7-66C5-94F3-D833-CDF665B221D1}"/>
+                <a16:creationId xmlns:a16="http://schemas.microsoft.com/office/drawing/2014/main" id="{AF6F599A-8CEA-EE69-4D4A-09E6DD83C8FE}"/>
               </a:ext>
             </a:extLst>
           </p:cNvPr>
@@ -8060,7 +8032,7 @@
           <p:cNvPr id="3" name="Marcador de contenido 2">
             <a:extLst>
               <a:ext uri="{FF2B5EF4-FFF2-40B4-BE49-F238E27FC236}">
-                <a16:creationId xmlns:a16="http://schemas.microsoft.com/office/drawing/2014/main" id="{A4FE553C-ED92-FF22-A769-A37102934312}"/>
+                <a16:creationId xmlns:a16="http://schemas.microsoft.com/office/drawing/2014/main" id="{F71A4F6F-394A-82CF-61F9-52D9CC2E8FD8}"/>
               </a:ext>
             </a:extLst>
           </p:cNvPr>
@@ -8077,62 +8049,44 @@
           <a:lstStyle/>
           <a:p>
             <a:r>
-              <a:rPr lang="es-PE" dirty="0"/>
-              <a:t>00-smoke-conexion - menú principal</a:t>
-            </a:r>
-          </a:p>
-          <a:p>
-            <a:r>
-              <a:rPr lang="es-PE" dirty="0"/>
-              <a:t>01-inicio-sesion - </a:t>
-            </a:r>
-            <a:r>
-              <a:rPr lang="es-PE" dirty="0" err="1"/>
-              <a:t>sessionId</a:t>
-            </a:r>
-            <a:endParaRPr lang="es-PE" dirty="0"/>
-          </a:p>
-          <a:p>
-            <a:r>
-              <a:rPr lang="es-PE" dirty="0"/>
-              <a:t>02 a 05 - opciones menú 1-4</a:t>
-            </a:r>
-          </a:p>
-          <a:p>
-            <a:r>
-              <a:rPr lang="es-PE" dirty="0"/>
-              <a:t>06-reglas-sesion - contrato </a:t>
-            </a:r>
-            <a:r>
-              <a:rPr lang="es-PE" dirty="0" err="1"/>
-              <a:t>stateful</a:t>
-            </a:r>
-            <a:endParaRPr lang="es-PE" dirty="0"/>
-          </a:p>
-          <a:p>
-            <a:r>
-              <a:rPr lang="es-PE" dirty="0"/>
+              <a:rPr lang="es-PE"/>
+              <a:t>00-smoke-conexion - menu principal</a:t>
+            </a:r>
+          </a:p>
+          <a:p>
+            <a:r>
+              <a:rPr lang="es-PE"/>
+              <a:t>01-inicio-sesion - sessionId</a:t>
+            </a:r>
+          </a:p>
+          <a:p>
+            <a:r>
+              <a:rPr lang="es-PE"/>
+              <a:t>02 a 05 - opciones menu 1-4</a:t>
+            </a:r>
+          </a:p>
+          <a:p>
+            <a:r>
+              <a:rPr lang="es-PE"/>
+              <a:t>06-reglas-sesion - contrato stateful</a:t>
+            </a:r>
+          </a:p>
+          <a:p>
+            <a:r>
+              <a:rPr lang="es-PE"/>
               <a:t>07-flujo-completo - E2E</a:t>
             </a:r>
           </a:p>
           <a:p>
             <a:r>
-              <a:rPr lang="es-PE" dirty="0"/>
+              <a:rPr lang="es-PE"/>
               <a:t>00-contracto-payload - 2 escenarios sin red</a:t>
             </a:r>
           </a:p>
           <a:p>
             <a:r>
-              <a:rPr lang="es-PE" dirty="0"/>
-              <a:t>Total: 12 escenarios en 9 </a:t>
-            </a:r>
-            <a:r>
-              <a:rPr lang="es-PE" dirty="0" err="1"/>
-              <a:t>features</a:t>
-            </a:r>
-            <a:r>
-              <a:rPr lang="es-PE" dirty="0"/>
-              <a:t> Karate</a:t>
+              <a:rPr lang="es-PE"/>
+              <a:t>Total: 12 escenarios en 9 features Karate</a:t>
             </a:r>
           </a:p>
         </p:txBody>
@@ -8140,7 +8094,7 @@
     </p:spTree>
     <p:extLst>
       <p:ext uri="{BB962C8B-B14F-4D97-AF65-F5344CB8AC3E}">
-        <p14:creationId xmlns:p14="http://schemas.microsoft.com/office/powerpoint/2010/main" val="3432885024"/>
+        <p14:creationId xmlns:p14="http://schemas.microsoft.com/office/powerpoint/2010/main" val="3444637055"/>
       </p:ext>
     </p:extLst>
   </p:cSld>
@@ -8172,7 +8126,7 @@
           <p:cNvPr id="2" name="Título 1">
             <a:extLst>
               <a:ext uri="{FF2B5EF4-FFF2-40B4-BE49-F238E27FC236}">
-                <a16:creationId xmlns:a16="http://schemas.microsoft.com/office/drawing/2014/main" id="{9E4D056A-41A3-B777-0F8F-E006BAAC5229}"/>
+                <a16:creationId xmlns:a16="http://schemas.microsoft.com/office/drawing/2014/main" id="{7C32ECD7-A193-F9CF-09D0-353470FA49AB}"/>
               </a:ext>
             </a:extLst>
           </p:cNvPr>
@@ -8189,10 +8143,10 @@
           <a:lstStyle/>
           <a:p>
             <a:r>
-              <a:rPr lang="es-ES" dirty="0"/>
-              <a:t>Métricas y traducción a negocio</a:t>
-            </a:r>
-            <a:endParaRPr lang="es-PE" dirty="0"/>
+              <a:rPr lang="es-ES"/>
+              <a:t>Metricas y traduccion a negocio</a:t>
+            </a:r>
+            <a:endParaRPr lang="es-PE"/>
           </a:p>
         </p:txBody>
       </p:sp>
@@ -8201,7 +8155,7 @@
           <p:cNvPr id="3" name="Marcador de contenido 2">
             <a:extLst>
               <a:ext uri="{FF2B5EF4-FFF2-40B4-BE49-F238E27FC236}">
-                <a16:creationId xmlns:a16="http://schemas.microsoft.com/office/drawing/2014/main" id="{5899D84D-DC6D-D1C4-CDC5-58EC0AF3402F}"/>
+                <a16:creationId xmlns:a16="http://schemas.microsoft.com/office/drawing/2014/main" id="{64F5B2E5-C425-9B3B-B655-5C09CE309CBF}"/>
               </a:ext>
             </a:extLst>
           </p:cNvPr>
@@ -8218,49 +8172,41 @@
           <a:lstStyle/>
           <a:p>
             <a:r>
-              <a:rPr lang="es-ES" dirty="0"/>
+              <a:rPr lang="es-ES"/>
               <a:t>Contrato: 2 de 2 OK - formato de mensajes correcto</a:t>
             </a:r>
           </a:p>
           <a:p>
             <a:r>
-              <a:rPr lang="es-ES" dirty="0"/>
-              <a:t>Integración: 10 escenarios listos (requiere red)</a:t>
-            </a:r>
-          </a:p>
-          <a:p>
-            <a:r>
-              <a:rPr lang="es-ES" dirty="0"/>
-              <a:t>Regresión estimada: menos de 3 minutos</a:t>
-            </a:r>
-          </a:p>
-          <a:p>
-            <a:r>
-              <a:rPr lang="es-ES" dirty="0"/>
-              <a:t>Reporte HTML: target/karate-</a:t>
-            </a:r>
-            <a:r>
-              <a:rPr lang="es-ES" dirty="0" err="1"/>
-              <a:t>reports</a:t>
-            </a:r>
-            <a:r>
-              <a:rPr lang="es-ES" dirty="0"/>
-              <a:t>/karate-summary.html</a:t>
-            </a:r>
-          </a:p>
-          <a:p>
-            <a:r>
-              <a:rPr lang="es-ES" dirty="0"/>
+              <a:rPr lang="es-ES"/>
+              <a:t>Integracion: 10 escenarios listos (requiere red)</a:t>
+            </a:r>
+          </a:p>
+          <a:p>
+            <a:r>
+              <a:rPr lang="es-ES"/>
+              <a:t>Regresion estimada: menos de 3 minutos</a:t>
+            </a:r>
+          </a:p>
+          <a:p>
+            <a:r>
+              <a:rPr lang="es-ES"/>
+              <a:t>Reporte HTML: target/karate-reports/karate-summary.html</a:t>
+            </a:r>
+          </a:p>
+          <a:p>
+            <a:r>
+              <a:rPr lang="es-ES"/>
               <a:t>Bloqueo: puerto 9898 no accesible sin VPN</a:t>
             </a:r>
-            <a:endParaRPr lang="es-PE" dirty="0"/>
+            <a:endParaRPr lang="es-PE"/>
           </a:p>
         </p:txBody>
       </p:sp>
     </p:spTree>
     <p:extLst>
       <p:ext uri="{BB962C8B-B14F-4D97-AF65-F5344CB8AC3E}">
-        <p14:creationId xmlns:p14="http://schemas.microsoft.com/office/powerpoint/2010/main" val="4197934329"/>
+        <p14:creationId xmlns:p14="http://schemas.microsoft.com/office/powerpoint/2010/main" val="3423068721"/>
       </p:ext>
     </p:extLst>
   </p:cSld>
@@ -8292,7 +8238,7 @@
           <p:cNvPr id="2" name="Título 1">
             <a:extLst>
               <a:ext uri="{FF2B5EF4-FFF2-40B4-BE49-F238E27FC236}">
-                <a16:creationId xmlns:a16="http://schemas.microsoft.com/office/drawing/2014/main" id="{69357A7F-45A7-ACE8-E975-312587C1CF36}"/>
+                <a16:creationId xmlns:a16="http://schemas.microsoft.com/office/drawing/2014/main" id="{5EA6B712-4C05-8335-8535-1322568524FA}"/>
               </a:ext>
             </a:extLst>
           </p:cNvPr>
@@ -8309,8 +8255,8 @@
           <a:lstStyle/>
           <a:p>
             <a:r>
-              <a:rPr lang="es-PE" dirty="0"/>
-              <a:t>Semáforo de calidad</a:t>
+              <a:rPr lang="es-PE"/>
+              <a:t>Semaforo de calidad</a:t>
             </a:r>
           </a:p>
         </p:txBody>
@@ -8320,7 +8266,7 @@
           <p:cNvPr id="3" name="Marcador de contenido 2">
             <a:extLst>
               <a:ext uri="{FF2B5EF4-FFF2-40B4-BE49-F238E27FC236}">
-                <a16:creationId xmlns:a16="http://schemas.microsoft.com/office/drawing/2014/main" id="{74941A5C-DE2D-B5E3-3252-6AD882A58050}"/>
+                <a16:creationId xmlns:a16="http://schemas.microsoft.com/office/drawing/2014/main" id="{9C6389C4-5387-0B6B-E092-54D731159A0E}"/>
               </a:ext>
             </a:extLst>
           </p:cNvPr>
@@ -8337,41 +8283,41 @@
           <a:lstStyle/>
           <a:p>
             <a:r>
-              <a:rPr lang="es-ES" dirty="0"/>
-              <a:t>VERDE: diseño de pruebas y reglas de sesión</a:t>
-            </a:r>
-          </a:p>
-          <a:p>
-            <a:r>
-              <a:rPr lang="es-ES" dirty="0"/>
-              <a:t>VERDE: automatización Happy Path + 4 opciones</a:t>
-            </a:r>
-          </a:p>
-          <a:p>
-            <a:r>
-              <a:rPr lang="es-ES" dirty="0"/>
-              <a:t>AMBAR: ejecución contra simulador (VPN/red)</a:t>
-            </a:r>
-          </a:p>
-          <a:p>
-            <a:r>
-              <a:rPr lang="es-ES" dirty="0"/>
+              <a:rPr lang="es-ES"/>
+              <a:t>VERDE: diseno de pruebas y reglas de sesion</a:t>
+            </a:r>
+          </a:p>
+          <a:p>
+            <a:r>
+              <a:rPr lang="es-ES"/>
+              <a:t>VERDE: automatizacion Happy Path + 4 opciones</a:t>
+            </a:r>
+          </a:p>
+          <a:p>
+            <a:r>
+              <a:rPr lang="es-ES"/>
+              <a:t>AMBAR: ejecucion contra simulador (VPN/red)</a:t>
+            </a:r>
+          </a:p>
+          <a:p>
+            <a:r>
+              <a:rPr lang="es-ES"/>
               <a:t>AMBAR: pruebas negativas de seguridad (fase 2)</a:t>
             </a:r>
           </a:p>
           <a:p>
             <a:r>
-              <a:rPr lang="es-ES" dirty="0"/>
-              <a:t>PENDIENTE: pruebas de estrés / escala (fase 2)</a:t>
-            </a:r>
-            <a:endParaRPr lang="es-PE" dirty="0"/>
+              <a:rPr lang="es-ES"/>
+              <a:t>PENDIENTE: pruebas de estres / escala (fase 2)</a:t>
+            </a:r>
+            <a:endParaRPr lang="es-PE"/>
           </a:p>
         </p:txBody>
       </p:sp>
     </p:spTree>
     <p:extLst>
       <p:ext uri="{BB962C8B-B14F-4D97-AF65-F5344CB8AC3E}">
-        <p14:creationId xmlns:p14="http://schemas.microsoft.com/office/powerpoint/2010/main" val="2885119294"/>
+        <p14:creationId xmlns:p14="http://schemas.microsoft.com/office/powerpoint/2010/main" val="775370629"/>
       </p:ext>
     </p:extLst>
   </p:cSld>
@@ -8403,7 +8349,7 @@
           <p:cNvPr id="2" name="Título 1">
             <a:extLst>
               <a:ext uri="{FF2B5EF4-FFF2-40B4-BE49-F238E27FC236}">
-                <a16:creationId xmlns:a16="http://schemas.microsoft.com/office/drawing/2014/main" id="{C1E49D41-12EC-0D52-F45A-253B0D112565}"/>
+                <a16:creationId xmlns:a16="http://schemas.microsoft.com/office/drawing/2014/main" id="{C800A2FE-68AA-1585-8E41-F173B9BE4133}"/>
               </a:ext>
             </a:extLst>
           </p:cNvPr>
@@ -8431,7 +8377,7 @@
           <p:cNvPr id="3" name="Marcador de contenido 2">
             <a:extLst>
               <a:ext uri="{FF2B5EF4-FFF2-40B4-BE49-F238E27FC236}">
-                <a16:creationId xmlns:a16="http://schemas.microsoft.com/office/drawing/2014/main" id="{39589DEF-B56E-E01E-577B-1563FBC7559C}"/>
+                <a16:creationId xmlns:a16="http://schemas.microsoft.com/office/drawing/2014/main" id="{99FF529F-7AC7-E9CA-FE6E-5332D32C5931}"/>
               </a:ext>
             </a:extLst>
           </p:cNvPr>
@@ -8448,32 +8394,32 @@
           <a:lstStyle/>
           <a:p>
             <a:r>
-              <a:rPr lang="es-PE" dirty="0"/>
-              <a:t>H1 - Suite alineada al documento técnico</a:t>
-            </a:r>
-          </a:p>
-          <a:p>
-            <a:r>
-              <a:rPr lang="es-PE" dirty="0"/>
+              <a:rPr lang="es-PE"/>
+              <a:t>H1 - Suite alineada al documento tecnico</a:t>
+            </a:r>
+          </a:p>
+          <a:p>
+            <a:r>
+              <a:rPr lang="es-PE"/>
               <a:t>H2 - Contrato validado sin red (2/2 OK)</a:t>
             </a:r>
           </a:p>
           <a:p>
             <a:r>
-              <a:rPr lang="es-PE" dirty="0"/>
-              <a:t>H3 - Integración bloqueada por acceso al servidor</a:t>
-            </a:r>
-          </a:p>
-          <a:p>
-            <a:r>
-              <a:rPr lang="es-PE" dirty="0"/>
+              <a:rPr lang="es-PE"/>
+              <a:t>H3 - Integracion bloqueada por acceso al servidor</a:t>
+            </a:r>
+          </a:p>
+          <a:p>
+            <a:r>
+              <a:rPr lang="es-PE"/>
               <a:t>H4 - Reportes Karate listos para auditoria</a:t>
             </a:r>
           </a:p>
           <a:p>
             <a:r>
-              <a:rPr lang="es-PE" dirty="0"/>
-              <a:t>Conclusión: herramienta lista; certificar ambiente</a:t>
+              <a:rPr lang="es-PE"/>
+              <a:t>Conclusion: herramienta lista; certificar ambiente</a:t>
             </a:r>
           </a:p>
         </p:txBody>
@@ -8481,7 +8427,7 @@
     </p:spTree>
     <p:extLst>
       <p:ext uri="{BB962C8B-B14F-4D97-AF65-F5344CB8AC3E}">
-        <p14:creationId xmlns:p14="http://schemas.microsoft.com/office/powerpoint/2010/main" val="226264450"/>
+        <p14:creationId xmlns:p14="http://schemas.microsoft.com/office/powerpoint/2010/main" val="3014963222"/>
       </p:ext>
     </p:extLst>
   </p:cSld>
@@ -8513,7 +8459,7 @@
           <p:cNvPr id="2" name="Título 1">
             <a:extLst>
               <a:ext uri="{FF2B5EF4-FFF2-40B4-BE49-F238E27FC236}">
-                <a16:creationId xmlns:a16="http://schemas.microsoft.com/office/drawing/2014/main" id="{C0CE419A-E56A-A6FB-DCF0-8AB48823097F}"/>
+                <a16:creationId xmlns:a16="http://schemas.microsoft.com/office/drawing/2014/main" id="{E8780102-AC43-08F2-84AC-67DA81462D66}"/>
               </a:ext>
             </a:extLst>
           </p:cNvPr>
@@ -8541,7 +8487,7 @@
           <p:cNvPr id="3" name="Marcador de contenido 2">
             <a:extLst>
               <a:ext uri="{FF2B5EF4-FFF2-40B4-BE49-F238E27FC236}">
-                <a16:creationId xmlns:a16="http://schemas.microsoft.com/office/drawing/2014/main" id="{0FA624B8-21A3-B5CF-6EBD-12FFA9D6F025}"/>
+                <a16:creationId xmlns:a16="http://schemas.microsoft.com/office/drawing/2014/main" id="{472CE59D-CB1E-AE84-0956-BD5B89B73BE3}"/>
               </a:ext>
             </a:extLst>
           </p:cNvPr>
@@ -8558,82 +8504,32 @@
           <a:lstStyle/>
           <a:p>
             <a:r>
-              <a:rPr lang="es-PE" dirty="0"/>
-              <a:t>P0 - Habilitar VPN o </a:t>
-            </a:r>
-            <a:r>
-              <a:rPr lang="es-PE" dirty="0" err="1"/>
-              <a:t>whitelist</a:t>
-            </a:r>
-            <a:r>
-              <a:rPr lang="es-PE" dirty="0"/>
-              <a:t> IP al simulador</a:t>
-            </a:r>
-          </a:p>
-          <a:p>
-            <a:r>
-              <a:rPr lang="es-PE" dirty="0"/>
-              <a:t>P0 - Ejecutar: </a:t>
-            </a:r>
-            <a:r>
-              <a:rPr lang="es-PE" dirty="0" err="1"/>
-              <a:t>mvn</a:t>
-            </a:r>
-            <a:r>
-              <a:rPr lang="es-PE" dirty="0"/>
-              <a:t> test -</a:t>
-            </a:r>
-            <a:r>
-              <a:rPr lang="es-PE" dirty="0" err="1"/>
-              <a:t>Dtest</a:t>
-            </a:r>
-            <a:r>
-              <a:rPr lang="es-PE" dirty="0"/>
-              <a:t>=</a:t>
-            </a:r>
-            <a:r>
-              <a:rPr lang="es-PE" dirty="0" err="1"/>
-              <a:t>UssdTestRunner</a:t>
-            </a:r>
-            <a:endParaRPr lang="es-PE" dirty="0"/>
-          </a:p>
-          <a:p>
-            <a:r>
-              <a:rPr lang="es-PE" dirty="0"/>
-              <a:t>P1 - Pipeline CI: contrato + integración </a:t>
-            </a:r>
-            <a:r>
-              <a:rPr lang="es-PE" dirty="0" err="1"/>
-              <a:t>nightly</a:t>
-            </a:r>
-            <a:endParaRPr lang="es-PE" dirty="0"/>
-          </a:p>
-          <a:p>
-            <a:r>
-              <a:rPr lang="es-PE" dirty="0"/>
-              <a:t>P1 - Pruebas negativas (</a:t>
-            </a:r>
-            <a:r>
-              <a:rPr lang="es-PE" dirty="0" err="1"/>
-              <a:t>sessionId</a:t>
-            </a:r>
-            <a:r>
-              <a:rPr lang="es-PE" dirty="0"/>
-              <a:t> inválido)</a:t>
-            </a:r>
-          </a:p>
-          <a:p>
-            <a:r>
-              <a:rPr lang="es-PE" dirty="0"/>
-              <a:t>P2 - Carga </a:t>
-            </a:r>
-            <a:r>
-              <a:rPr lang="es-PE" dirty="0" err="1"/>
-              <a:t>JMeter</a:t>
-            </a:r>
-            <a:r>
-              <a:rPr lang="es-PE" dirty="0"/>
-              <a:t> + monitoreo sintético *999#</a:t>
+              <a:rPr lang="es-PE"/>
+              <a:t>P0 - Habilitar VPN o whitelist IP al simulador</a:t>
+            </a:r>
+          </a:p>
+          <a:p>
+            <a:r>
+              <a:rPr lang="es-PE"/>
+              <a:t>P0 - Ejecutar: mvn test -Dtest=UssdTestRunner</a:t>
+            </a:r>
+          </a:p>
+          <a:p>
+            <a:r>
+              <a:rPr lang="es-PE"/>
+              <a:t>P1 - Pipeline CI: contrato + integracion nightly</a:t>
+            </a:r>
+          </a:p>
+          <a:p>
+            <a:r>
+              <a:rPr lang="es-PE"/>
+              <a:t>P1 - Pruebas negativas (sessionId invalido)</a:t>
+            </a:r>
+          </a:p>
+          <a:p>
+            <a:r>
+              <a:rPr lang="es-PE"/>
+              <a:t>P2 - Carga JMeter + monitoreo sintetico *999#</a:t>
             </a:r>
           </a:p>
         </p:txBody>
@@ -8641,7 +8537,7 @@
     </p:spTree>
     <p:extLst>
       <p:ext uri="{BB962C8B-B14F-4D97-AF65-F5344CB8AC3E}">
-        <p14:creationId xmlns:p14="http://schemas.microsoft.com/office/powerpoint/2010/main" val="694327248"/>
+        <p14:creationId xmlns:p14="http://schemas.microsoft.com/office/powerpoint/2010/main" val="743026207"/>
       </p:ext>
     </p:extLst>
   </p:cSld>
@@ -8673,7 +8569,7 @@
           <p:cNvPr id="2" name="Título 1">
             <a:extLst>
               <a:ext uri="{FF2B5EF4-FFF2-40B4-BE49-F238E27FC236}">
-                <a16:creationId xmlns:a16="http://schemas.microsoft.com/office/drawing/2014/main" id="{03DDE5A5-1A7A-0626-6AE0-67CA5727097D}"/>
+                <a16:creationId xmlns:a16="http://schemas.microsoft.com/office/drawing/2014/main" id="{DB152701-AC94-F507-445C-A52B00A3A0AE}"/>
               </a:ext>
             </a:extLst>
           </p:cNvPr>
@@ -8702,7 +8598,7 @@
           <p:cNvPr id="3" name="Marcador de contenido 2">
             <a:extLst>
               <a:ext uri="{FF2B5EF4-FFF2-40B4-BE49-F238E27FC236}">
-                <a16:creationId xmlns:a16="http://schemas.microsoft.com/office/drawing/2014/main" id="{57F4C250-329E-1150-047B-792FBE3D2B67}"/>
+                <a16:creationId xmlns:a16="http://schemas.microsoft.com/office/drawing/2014/main" id="{59A92ADC-45A3-6A26-E5A4-A958DD545425}"/>
               </a:ext>
             </a:extLst>
           </p:cNvPr>
@@ -8719,58 +8615,41 @@
           <a:lstStyle/>
           <a:p>
             <a:r>
-              <a:rPr lang="es-ES" dirty="0"/>
-              <a:t>Hoy: regresión funcional automática </a:t>
-            </a:r>
-            <a:r>
-              <a:rPr lang="es-ES" dirty="0" err="1"/>
-              <a:t>pre-release</a:t>
-            </a:r>
-            <a:endParaRPr lang="es-ES" dirty="0"/>
-          </a:p>
-          <a:p>
-            <a:r>
-              <a:rPr lang="es-ES" dirty="0"/>
+              <a:rPr lang="es-ES"/>
+              <a:t>Hoy: regresion funcional automatica pre-release</a:t>
+            </a:r>
+          </a:p>
+          <a:p>
+            <a:r>
+              <a:rPr lang="es-ES"/>
               <a:t>Fase 2: sesiones concurrentes, latencia p95</a:t>
             </a:r>
           </a:p>
           <a:p>
             <a:r>
-              <a:rPr lang="es-ES" dirty="0" err="1"/>
-              <a:t>Produccion</a:t>
-            </a:r>
-            <a:r>
-              <a:rPr lang="es-ES" dirty="0"/>
-              <a:t>: robot *999# cada 5 minutos</a:t>
-            </a:r>
-          </a:p>
-          <a:p>
-            <a:r>
-              <a:rPr lang="es-ES" dirty="0"/>
-              <a:t>Arquitectura: TTL de </a:t>
-            </a:r>
-            <a:r>
-              <a:rPr lang="es-ES" dirty="0" err="1"/>
-              <a:t>sessionId</a:t>
-            </a:r>
-            <a:r>
-              <a:rPr lang="es-ES" dirty="0"/>
-              <a:t>, límites por MSISDN</a:t>
-            </a:r>
-          </a:p>
-          <a:p>
-            <a:r>
-              <a:rPr lang="es-ES" dirty="0"/>
+              <a:rPr lang="es-ES"/>
+              <a:t>Produccion: robot *999# cada 5 minutos</a:t>
+            </a:r>
+          </a:p>
+          <a:p>
+            <a:r>
+              <a:rPr lang="es-ES"/>
+              <a:t>Arquitectura: TTL de sessionId, limites por MSISDN</a:t>
+            </a:r>
+          </a:p>
+          <a:p>
+            <a:r>
+              <a:rPr lang="es-ES"/>
               <a:t>Funcional + carga + monitoreo = defensa en profundidad</a:t>
             </a:r>
-            <a:endParaRPr lang="es-PE" dirty="0"/>
+            <a:endParaRPr lang="es-PE"/>
           </a:p>
         </p:txBody>
       </p:sp>
     </p:spTree>
     <p:extLst>
       <p:ext uri="{BB962C8B-B14F-4D97-AF65-F5344CB8AC3E}">
-        <p14:creationId xmlns:p14="http://schemas.microsoft.com/office/powerpoint/2010/main" val="2942107834"/>
+        <p14:creationId xmlns:p14="http://schemas.microsoft.com/office/powerpoint/2010/main" val="866678203"/>
       </p:ext>
     </p:extLst>
   </p:cSld>
@@ -8802,7 +8681,7 @@
           <p:cNvPr id="2" name="Título 1">
             <a:extLst>
               <a:ext uri="{FF2B5EF4-FFF2-40B4-BE49-F238E27FC236}">
-                <a16:creationId xmlns:a16="http://schemas.microsoft.com/office/drawing/2014/main" id="{2149B3C2-5894-0D23-8452-FEB33990EC62}"/>
+                <a16:creationId xmlns:a16="http://schemas.microsoft.com/office/drawing/2014/main" id="{AB67D8EF-7E6D-2D7E-04CF-3F65FED3DC8C}"/>
               </a:ext>
             </a:extLst>
           </p:cNvPr>
@@ -8830,7 +8709,7 @@
           <p:cNvPr id="3" name="Marcador de contenido 2">
             <a:extLst>
               <a:ext uri="{FF2B5EF4-FFF2-40B4-BE49-F238E27FC236}">
-                <a16:creationId xmlns:a16="http://schemas.microsoft.com/office/drawing/2014/main" id="{3A15813A-D543-E321-DC72-2FDA9D673C7E}"/>
+                <a16:creationId xmlns:a16="http://schemas.microsoft.com/office/drawing/2014/main" id="{EB181893-2E6E-1547-E401-EF0FA7E37B65}"/>
               </a:ext>
             </a:extLst>
           </p:cNvPr>
@@ -8847,94 +8726,32 @@
           <a:lstStyle/>
           <a:p>
             <a:r>
-              <a:rPr lang="es-PE" dirty="0"/>
-              <a:t>Sin red: </a:t>
-            </a:r>
-            <a:r>
-              <a:rPr lang="es-PE" dirty="0" err="1"/>
-              <a:t>mvn</a:t>
-            </a:r>
-            <a:r>
-              <a:rPr lang="es-PE" dirty="0"/>
-              <a:t> test -</a:t>
-            </a:r>
-            <a:r>
-              <a:rPr lang="es-PE" dirty="0" err="1"/>
-              <a:t>Poffline</a:t>
-            </a:r>
-            <a:endParaRPr lang="es-PE" dirty="0"/>
-          </a:p>
-          <a:p>
-            <a:r>
-              <a:rPr lang="es-PE" dirty="0"/>
-              <a:t>Con VPN: </a:t>
-            </a:r>
-            <a:r>
-              <a:rPr lang="es-PE" dirty="0" err="1"/>
-              <a:t>mvn</a:t>
-            </a:r>
-            <a:r>
-              <a:rPr lang="es-PE" dirty="0"/>
-              <a:t> test -</a:t>
-            </a:r>
-            <a:r>
-              <a:rPr lang="es-PE" dirty="0" err="1"/>
-              <a:t>Dtest</a:t>
-            </a:r>
-            <a:r>
-              <a:rPr lang="es-PE" dirty="0"/>
-              <a:t>=</a:t>
-            </a:r>
-            <a:r>
-              <a:rPr lang="es-PE" dirty="0" err="1"/>
-              <a:t>UssdTestRunner</a:t>
-            </a:r>
-            <a:endParaRPr lang="es-PE" dirty="0"/>
-          </a:p>
-          <a:p>
-            <a:r>
-              <a:rPr lang="es-PE" dirty="0"/>
-              <a:t>Red: Test-</a:t>
-            </a:r>
-            <a:r>
-              <a:rPr lang="es-PE" dirty="0" err="1"/>
-              <a:t>NetConnection</a:t>
-            </a:r>
-            <a:r>
-              <a:rPr lang="es-PE" dirty="0"/>
-              <a:t> 181.224.248.52 -Port 9898</a:t>
-            </a:r>
-          </a:p>
-          <a:p>
-            <a:r>
-              <a:rPr lang="es-PE" dirty="0" err="1"/>
-              <a:t>Docs</a:t>
-            </a:r>
-            <a:r>
-              <a:rPr lang="es-PE" dirty="0"/>
-              <a:t>: docs/REPORTE_EJECUTIVO_CEO.md</a:t>
-            </a:r>
-          </a:p>
-          <a:p>
-            <a:r>
-              <a:rPr lang="es-PE" dirty="0"/>
-              <a:t>Repo: </a:t>
-            </a:r>
-            <a:r>
-              <a:rPr lang="es-PE" dirty="0" err="1"/>
-              <a:t>RetoQA</a:t>
-            </a:r>
-            <a:r>
-              <a:rPr lang="es-PE" dirty="0"/>
-              <a:t> (GitHub/</a:t>
-            </a:r>
-            <a:r>
-              <a:rPr lang="es-PE" dirty="0" err="1"/>
-              <a:t>GitLab</a:t>
-            </a:r>
-            <a:r>
-              <a:rPr lang="es-PE" dirty="0"/>
-              <a:t>)</a:t>
+              <a:rPr lang="es-PE"/>
+              <a:t>Sin red: mvn test -Poffline</a:t>
+            </a:r>
+          </a:p>
+          <a:p>
+            <a:r>
+              <a:rPr lang="es-PE"/>
+              <a:t>Con VPN: mvn test -Dtest=UssdTestRunner</a:t>
+            </a:r>
+          </a:p>
+          <a:p>
+            <a:r>
+              <a:rPr lang="es-PE"/>
+              <a:t>Red: Test-NetConnection 181.224.248.52 -Port 9898</a:t>
+            </a:r>
+          </a:p>
+          <a:p>
+            <a:r>
+              <a:rPr lang="es-PE"/>
+              <a:t>Docs: docs/REPORTE_EJECUTIVO_CEO.md</a:t>
+            </a:r>
+          </a:p>
+          <a:p>
+            <a:r>
+              <a:rPr lang="es-PE"/>
+              <a:t>Repo: RetoQA (GitHub/GitLab)</a:t>
             </a:r>
           </a:p>
         </p:txBody>
@@ -8942,7 +8759,7 @@
     </p:spTree>
     <p:extLst>
       <p:ext uri="{BB962C8B-B14F-4D97-AF65-F5344CB8AC3E}">
-        <p14:creationId xmlns:p14="http://schemas.microsoft.com/office/powerpoint/2010/main" val="3253712319"/>
+        <p14:creationId xmlns:p14="http://schemas.microsoft.com/office/powerpoint/2010/main" val="2234719441"/>
       </p:ext>
     </p:extLst>
   </p:cSld>
@@ -8974,7 +8791,7 @@
           <p:cNvPr id="2" name="Título 1">
             <a:extLst>
               <a:ext uri="{FF2B5EF4-FFF2-40B4-BE49-F238E27FC236}">
-                <a16:creationId xmlns:a16="http://schemas.microsoft.com/office/drawing/2014/main" id="{392F7B0C-6CE3-B593-527C-B25741B06F09}"/>
+                <a16:creationId xmlns:a16="http://schemas.microsoft.com/office/drawing/2014/main" id="{F92512EF-4151-1F43-B1F0-D95384A0222A}"/>
               </a:ext>
             </a:extLst>
           </p:cNvPr>
@@ -9002,7 +8819,7 @@
           <p:cNvPr id="3" name="Marcador de contenido 2">
             <a:extLst>
               <a:ext uri="{FF2B5EF4-FFF2-40B4-BE49-F238E27FC236}">
-                <a16:creationId xmlns:a16="http://schemas.microsoft.com/office/drawing/2014/main" id="{9176725C-70A6-C3FA-CB62-879285A999BC}"/>
+                <a16:creationId xmlns:a16="http://schemas.microsoft.com/office/drawing/2014/main" id="{7C14BD58-6443-2125-8072-35192CA1220E}"/>
               </a:ext>
             </a:extLst>
           </p:cNvPr>
@@ -9019,47 +8836,31 @@
           <a:lstStyle/>
           <a:p>
             <a:r>
-              <a:rPr lang="es-PE" dirty="0"/>
-              <a:t>Repositorio: código + </a:t>
-            </a:r>
-            <a:r>
-              <a:rPr lang="es-PE" dirty="0" err="1"/>
-              <a:t>features</a:t>
-            </a:r>
-            <a:r>
-              <a:rPr lang="es-PE" dirty="0"/>
-              <a:t> Karate + proto</a:t>
-            </a:r>
-          </a:p>
-          <a:p>
-            <a:r>
-              <a:rPr lang="es-PE" dirty="0"/>
+              <a:rPr lang="es-PE"/>
+              <a:t>Repositorio: codigo + features Karate + proto</a:t>
+            </a:r>
+          </a:p>
+          <a:p>
+            <a:r>
+              <a:rPr lang="es-PE"/>
               <a:t>ESTRATEGIA_QA.md - estrategia profesional</a:t>
             </a:r>
           </a:p>
           <a:p>
             <a:r>
-              <a:rPr lang="es-PE" dirty="0"/>
-              <a:t>REPORTE_EJECUTIVO_CEO.md - visión dirección</a:t>
-            </a:r>
-          </a:p>
-          <a:p>
-            <a:r>
-              <a:rPr lang="es-PE" dirty="0"/>
-              <a:t>GUIA_PRESENTACION.md - </a:t>
-            </a:r>
-            <a:r>
-              <a:rPr lang="es-PE" dirty="0" err="1"/>
-              <a:t>guión</a:t>
-            </a:r>
-            <a:r>
-              <a:rPr lang="es-PE" dirty="0"/>
-              <a:t> de presentación</a:t>
-            </a:r>
-          </a:p>
-          <a:p>
-            <a:r>
-              <a:rPr lang="es-PE" dirty="0"/>
+              <a:rPr lang="es-PE"/>
+              <a:t>REPORTE_EJECUTIVO_CEO.md - vision direccion</a:t>
+            </a:r>
+          </a:p>
+          <a:p>
+            <a:r>
+              <a:rPr lang="es-PE"/>
+              <a:t>GUIA_PRESENTACION.md - guion de presentacion</a:t>
+            </a:r>
+          </a:p>
+          <a:p>
+            <a:r>
+              <a:rPr lang="es-PE"/>
               <a:t>PPT + reportes HTML de evidencia</a:t>
             </a:r>
           </a:p>
@@ -9068,7 +8869,7 @@
     </p:spTree>
     <p:extLst>
       <p:ext uri="{BB962C8B-B14F-4D97-AF65-F5344CB8AC3E}">
-        <p14:creationId xmlns:p14="http://schemas.microsoft.com/office/powerpoint/2010/main" val="1411979170"/>
+        <p14:creationId xmlns:p14="http://schemas.microsoft.com/office/powerpoint/2010/main" val="2112376573"/>
       </p:ext>
     </p:extLst>
   </p:cSld>
@@ -9100,7 +8901,7 @@
           <p:cNvPr id="2" name="Título 1">
             <a:extLst>
               <a:ext uri="{FF2B5EF4-FFF2-40B4-BE49-F238E27FC236}">
-                <a16:creationId xmlns:a16="http://schemas.microsoft.com/office/drawing/2014/main" id="{E63AA66F-728C-96C4-3C12-7D3025F15E9E}"/>
+                <a16:creationId xmlns:a16="http://schemas.microsoft.com/office/drawing/2014/main" id="{FB4B3E97-C117-0574-1321-5D709F562F6E}"/>
               </a:ext>
             </a:extLst>
           </p:cNvPr>
@@ -9128,7 +8929,7 @@
           <p:cNvPr id="3" name="Marcador de contenido 2">
             <a:extLst>
               <a:ext uri="{FF2B5EF4-FFF2-40B4-BE49-F238E27FC236}">
-                <a16:creationId xmlns:a16="http://schemas.microsoft.com/office/drawing/2014/main" id="{1E9A1D5F-5D25-CF80-0454-95DC02C1DDBA}"/>
+                <a16:creationId xmlns:a16="http://schemas.microsoft.com/office/drawing/2014/main" id="{5B35E123-E1E6-21AC-00AA-79707734ADCF}"/>
               </a:ext>
             </a:extLst>
           </p:cNvPr>
@@ -9145,80 +8946,59 @@
           <a:lstStyle/>
           <a:p>
             <a:r>
-              <a:rPr lang="es-ES" dirty="0"/>
+              <a:rPr lang="es-ES"/>
               <a:t>Contexto de negocio: canal USSD</a:t>
             </a:r>
           </a:p>
           <a:p>
             <a:r>
-              <a:rPr lang="es-ES" dirty="0"/>
+              <a:rPr lang="es-ES"/>
               <a:t>Objetivo del reto y alcance</a:t>
             </a:r>
           </a:p>
           <a:p>
             <a:r>
-              <a:rPr lang="es-ES" dirty="0"/>
-              <a:t>Estrategia y </a:t>
-            </a:r>
-            <a:r>
-              <a:rPr lang="es-ES" dirty="0" err="1"/>
-              <a:t>framework</a:t>
-            </a:r>
-            <a:r>
-              <a:rPr lang="es-ES" dirty="0"/>
-              <a:t> (Karate + </a:t>
-            </a:r>
-            <a:r>
-              <a:rPr lang="es-ES" dirty="0" err="1"/>
-              <a:t>gRPC</a:t>
-            </a:r>
-            <a:r>
-              <a:rPr lang="es-ES" dirty="0"/>
-              <a:t>)</a:t>
-            </a:r>
-          </a:p>
-          <a:p>
-            <a:r>
-              <a:rPr lang="es-ES" dirty="0"/>
+              <a:rPr lang="es-ES"/>
+              <a:t>Estrategia y framework (Karate + gRPC)</a:t>
+            </a:r>
+          </a:p>
+          <a:p>
+            <a:r>
+              <a:rPr lang="es-ES"/>
               <a:t>Arquitectura de la suite de pruebas</a:t>
             </a:r>
           </a:p>
           <a:p>
             <a:r>
-              <a:rPr lang="es-ES" dirty="0"/>
-              <a:t>Reglas críticas: sesiones </a:t>
-            </a:r>
-            <a:r>
-              <a:rPr lang="es-ES" dirty="0" err="1"/>
-              <a:t>stateful</a:t>
-            </a:r>
-            <a:endParaRPr lang="es-ES" dirty="0"/>
-          </a:p>
-          <a:p>
-            <a:r>
-              <a:rPr lang="es-ES" dirty="0"/>
-              <a:t>Resultados, riesgos y semáforo</a:t>
-            </a:r>
-          </a:p>
-          <a:p>
-            <a:r>
-              <a:rPr lang="es-ES" dirty="0"/>
-              <a:t>Escalabilidad y próximos pasos</a:t>
-            </a:r>
-          </a:p>
-          <a:p>
-            <a:r>
-              <a:rPr lang="es-ES" dirty="0"/>
+              <a:rPr lang="es-ES"/>
+              <a:t>Reglas criticas: sesiones stateful</a:t>
+            </a:r>
+          </a:p>
+          <a:p>
+            <a:r>
+              <a:rPr lang="es-ES"/>
+              <a:t>Resultados, riesgos y semaforo</a:t>
+            </a:r>
+          </a:p>
+          <a:p>
+            <a:r>
+              <a:rPr lang="es-ES"/>
+              <a:t>Escalabilidad y proximos pasos</a:t>
+            </a:r>
+          </a:p>
+          <a:p>
+            <a:r>
+              <a:rPr lang="es-ES"/>
               <a:t>Demo y entregables</a:t>
             </a:r>
-            <a:endParaRPr lang="es-PE" dirty="0"/>
+            <a:endParaRPr lang="es-PE"/>
           </a:p>
         </p:txBody>
       </p:sp>
     </p:spTree>
     <p:extLst>
       <p:ext uri="{BB962C8B-B14F-4D97-AF65-F5344CB8AC3E}">
-        <p14:creationId xmlns:p14="http://schemas.microsoft.com/office/powerpoint/2010/main" val="1236411584"/>
+        <p14:creationId xmlns:p14="http://schemas.microsoft.com/office/powerpoint/2010/main" val="1166964529"/>
       </p:ext>
     </p:extLst>
   </p:cSld>
@@ -9250,7 +9030,7 @@
           <p:cNvPr id="2" name="Título 1">
             <a:extLst>
               <a:ext uri="{FF2B5EF4-FFF2-40B4-BE49-F238E27FC236}">
-                <a16:creationId xmlns:a16="http://schemas.microsoft.com/office/drawing/2014/main" id="{342BC89E-872F-0CE3-E0CA-A86B36A159F9}"/>
+                <a16:creationId xmlns:a16="http://schemas.microsoft.com/office/drawing/2014/main" id="{9B22287B-02DA-9D0D-ACB5-9F4DFDD6B472}"/>
               </a:ext>
             </a:extLst>
           </p:cNvPr>
@@ -9278,7 +9058,7 @@
           <p:cNvPr id="3" name="Subtítulo 2">
             <a:extLst>
               <a:ext uri="{FF2B5EF4-FFF2-40B4-BE49-F238E27FC236}">
-                <a16:creationId xmlns:a16="http://schemas.microsoft.com/office/drawing/2014/main" id="{37541336-F2D2-3C59-DEC8-62A7BEDD8F93}"/>
+                <a16:creationId xmlns:a16="http://schemas.microsoft.com/office/drawing/2014/main" id="{4C5420D7-4B8B-7AE8-3AA1-D4565E0E044A}"/>
               </a:ext>
             </a:extLst>
           </p:cNvPr>
@@ -9295,21 +9075,17 @@
           <a:lstStyle/>
           <a:p>
             <a:r>
-              <a:rPr lang="es-ES" dirty="0"/>
-              <a:t>Próximo paso: habilitar ambiente y certificar integración </a:t>
-            </a:r>
-            <a:r>
-              <a:rPr lang="es-ES" dirty="0" err="1"/>
-              <a:t>gRPC</a:t>
-            </a:r>
-            <a:endParaRPr lang="es-PE" dirty="0"/>
+              <a:rPr lang="es-ES"/>
+              <a:t>Preguntas`nProximo paso: habilitar ambiente y certificar integracion gRPC</a:t>
+            </a:r>
+            <a:endParaRPr lang="es-PE"/>
           </a:p>
         </p:txBody>
       </p:sp>
     </p:spTree>
     <p:extLst>
       <p:ext uri="{BB962C8B-B14F-4D97-AF65-F5344CB8AC3E}">
-        <p14:creationId xmlns:p14="http://schemas.microsoft.com/office/powerpoint/2010/main" val="4227540057"/>
+        <p14:creationId xmlns:p14="http://schemas.microsoft.com/office/powerpoint/2010/main" val="2369279411"/>
       </p:ext>
     </p:extLst>
   </p:cSld>
@@ -9341,7 +9117,7 @@
           <p:cNvPr id="2" name="Título 1">
             <a:extLst>
               <a:ext uri="{FF2B5EF4-FFF2-40B4-BE49-F238E27FC236}">
-                <a16:creationId xmlns:a16="http://schemas.microsoft.com/office/drawing/2014/main" id="{A0CAA19D-7DC8-F081-2E94-4EB23092396B}"/>
+                <a16:creationId xmlns:a16="http://schemas.microsoft.com/office/drawing/2014/main" id="{93646D41-200D-18F3-AF7F-E2991FE93E32}"/>
               </a:ext>
             </a:extLst>
           </p:cNvPr>
@@ -9358,10 +9134,10 @@
           <a:lstStyle/>
           <a:p>
             <a:r>
-              <a:rPr lang="es-ES" dirty="0"/>
-              <a:t>¿Qué es USSD y por qué importa?</a:t>
-            </a:r>
-            <a:endParaRPr lang="es-PE" dirty="0"/>
+              <a:rPr lang="es-ES"/>
+              <a:t>Que es USSD y por que importa</a:t>
+            </a:r>
+            <a:endParaRPr lang="es-PE"/>
           </a:p>
         </p:txBody>
       </p:sp>
@@ -9370,7 +9146,7 @@
           <p:cNvPr id="3" name="Marcador de contenido 2">
             <a:extLst>
               <a:ext uri="{FF2B5EF4-FFF2-40B4-BE49-F238E27FC236}">
-                <a16:creationId xmlns:a16="http://schemas.microsoft.com/office/drawing/2014/main" id="{3C257EB9-87AA-34AE-A227-0CD98099DD0C}"/>
+                <a16:creationId xmlns:a16="http://schemas.microsoft.com/office/drawing/2014/main" id="{24DE219D-0FC7-B05B-E20D-ADF0454BE636}"/>
               </a:ext>
             </a:extLst>
           </p:cNvPr>
@@ -9387,57 +9163,41 @@
           <a:lstStyle/>
           <a:p>
             <a:r>
-              <a:rPr lang="es-ES" dirty="0"/>
-              <a:t>Canal *999#: menú en el celular sin app</a:t>
-            </a:r>
-          </a:p>
-          <a:p>
-            <a:r>
-              <a:rPr lang="es-ES" dirty="0"/>
+              <a:rPr lang="es-ES"/>
+              <a:t>Canal *999#: menu en el celular sin app</a:t>
+            </a:r>
+          </a:p>
+          <a:p>
+            <a:r>
+              <a:rPr lang="es-ES"/>
               <a:t>Alto volumen: saldo, recargas, movimientos</a:t>
             </a:r>
           </a:p>
           <a:p>
             <a:r>
-              <a:rPr lang="es-ES" dirty="0"/>
-              <a:t>Un fallo impacta reputación del operador</a:t>
-            </a:r>
-          </a:p>
-          <a:p>
-            <a:r>
-              <a:rPr lang="es-ES" dirty="0"/>
-              <a:t>Recarga (opción 2) impacta ingresos</a:t>
-            </a:r>
-          </a:p>
-          <a:p>
-            <a:r>
-              <a:rPr lang="es-ES" dirty="0"/>
-              <a:t>Integración interna vía </a:t>
-            </a:r>
-            <a:r>
-              <a:rPr lang="es-ES" dirty="0" err="1"/>
-              <a:t>gRPC</a:t>
-            </a:r>
-            <a:r>
-              <a:rPr lang="es-ES" dirty="0"/>
-              <a:t> (</a:t>
-            </a:r>
-            <a:r>
-              <a:rPr lang="es-ES" dirty="0" err="1"/>
-              <a:t>UssdCmd</a:t>
-            </a:r>
-            <a:r>
-              <a:rPr lang="es-ES" dirty="0"/>
-              <a:t>)</a:t>
-            </a:r>
-            <a:endParaRPr lang="es-PE" dirty="0"/>
+              <a:rPr lang="es-ES"/>
+              <a:t>Un fallo impacta reputacion del operador</a:t>
+            </a:r>
+          </a:p>
+          <a:p>
+            <a:r>
+              <a:rPr lang="es-ES"/>
+              <a:t>Recarga (opcion 2) impacta ingresos</a:t>
+            </a:r>
+          </a:p>
+          <a:p>
+            <a:r>
+              <a:rPr lang="es-ES"/>
+              <a:t>Integracion interna via gRPC (UssdCmd)</a:t>
+            </a:r>
+            <a:endParaRPr lang="es-PE"/>
           </a:p>
         </p:txBody>
       </p:sp>
     </p:spTree>
     <p:extLst>
       <p:ext uri="{BB962C8B-B14F-4D97-AF65-F5344CB8AC3E}">
-        <p14:creationId xmlns:p14="http://schemas.microsoft.com/office/powerpoint/2010/main" val="3730733656"/>
+        <p14:creationId xmlns:p14="http://schemas.microsoft.com/office/powerpoint/2010/main" val="2763564889"/>
       </p:ext>
     </p:extLst>
   </p:cSld>
@@ -9469,7 +9229,7 @@
           <p:cNvPr id="2" name="Título 1">
             <a:extLst>
               <a:ext uri="{FF2B5EF4-FFF2-40B4-BE49-F238E27FC236}">
-                <a16:creationId xmlns:a16="http://schemas.microsoft.com/office/drawing/2014/main" id="{490493C1-85AF-EF12-B99B-6B256E0C38D3}"/>
+                <a16:creationId xmlns:a16="http://schemas.microsoft.com/office/drawing/2014/main" id="{EC9D30C6-73D8-E61A-94FD-FDFE65E2C27B}"/>
               </a:ext>
             </a:extLst>
           </p:cNvPr>
@@ -9497,7 +9257,7 @@
           <p:cNvPr id="3" name="Marcador de contenido 2">
             <a:extLst>
               <a:ext uri="{FF2B5EF4-FFF2-40B4-BE49-F238E27FC236}">
-                <a16:creationId xmlns:a16="http://schemas.microsoft.com/office/drawing/2014/main" id="{0DF71996-2EB3-CF91-3471-1A702CDCAE5A}"/>
+                <a16:creationId xmlns:a16="http://schemas.microsoft.com/office/drawing/2014/main" id="{F263ADFB-E9BB-62BA-A143-D2E0EDB9AAF0}"/>
               </a:ext>
             </a:extLst>
           </p:cNvPr>
@@ -9514,74 +9274,40 @@
           <a:lstStyle/>
           <a:p>
             <a:r>
-              <a:rPr lang="es-PE" dirty="0"/>
-              <a:t>Validar flujo de navegación del menú USSD</a:t>
-            </a:r>
-          </a:p>
-          <a:p>
-            <a:r>
-              <a:rPr lang="es-PE" dirty="0"/>
-              <a:t>Asegurar integridad de sesiones </a:t>
-            </a:r>
-            <a:r>
-              <a:rPr lang="es-PE" dirty="0" err="1"/>
-              <a:t>stateful</a:t>
-            </a:r>
-            <a:endParaRPr lang="es-PE" dirty="0"/>
-          </a:p>
-          <a:p>
-            <a:r>
-              <a:rPr lang="es-PE" dirty="0"/>
-              <a:t>Cumplir reglas: </a:t>
-            </a:r>
-            <a:r>
-              <a:rPr lang="es-PE" dirty="0" err="1"/>
-              <a:t>sessionId</a:t>
-            </a:r>
-            <a:r>
-              <a:rPr lang="es-PE" dirty="0"/>
-              <a:t>, </a:t>
-            </a:r>
-            <a:r>
-              <a:rPr lang="es-PE" dirty="0" err="1"/>
-              <a:t>msisdn</a:t>
-            </a:r>
-            <a:r>
-              <a:rPr lang="es-PE" dirty="0"/>
-              <a:t>, campos fijos</a:t>
-            </a:r>
-          </a:p>
-          <a:p>
-            <a:r>
-              <a:rPr lang="es-PE" dirty="0"/>
-              <a:t>Entregar estrategia QA + automatización + reporte CEO</a:t>
-            </a:r>
-          </a:p>
-          <a:p>
-            <a:r>
-              <a:rPr lang="es-PE" dirty="0"/>
-              <a:t>Servidor: 181.224.248.52:9898 - </a:t>
-            </a:r>
-            <a:r>
-              <a:rPr lang="es-PE" dirty="0" err="1"/>
-              <a:t>UssdCmd</a:t>
-            </a:r>
-            <a:r>
-              <a:rPr lang="es-PE" dirty="0"/>
-              <a:t>/</a:t>
-            </a:r>
-            <a:r>
-              <a:rPr lang="es-PE" dirty="0" err="1"/>
-              <a:t>UssdCmd</a:t>
-            </a:r>
-            <a:endParaRPr lang="es-PE" dirty="0"/>
+              <a:rPr lang="es-PE"/>
+              <a:t>Validar flujo de navegacion del menu USSD</a:t>
+            </a:r>
+          </a:p>
+          <a:p>
+            <a:r>
+              <a:rPr lang="es-PE"/>
+              <a:t>Asegurar integridad de sesiones stateful</a:t>
+            </a:r>
+          </a:p>
+          <a:p>
+            <a:r>
+              <a:rPr lang="es-PE"/>
+              <a:t>Cumplir reglas: sessionId, msisdn, campos fijos</a:t>
+            </a:r>
+          </a:p>
+          <a:p>
+            <a:r>
+              <a:rPr lang="es-PE"/>
+              <a:t>Entregar estrategia QA + automatizacion + reporte CEO</a:t>
+            </a:r>
+          </a:p>
+          <a:p>
+            <a:r>
+              <a:rPr lang="es-PE"/>
+              <a:t>Servidor: 181.224.248.52:9898 - UssdCmd/UssdCmd</a:t>
+            </a:r>
           </a:p>
         </p:txBody>
       </p:sp>
     </p:spTree>
     <p:extLst>
       <p:ext uri="{BB962C8B-B14F-4D97-AF65-F5344CB8AC3E}">
-        <p14:creationId xmlns:p14="http://schemas.microsoft.com/office/powerpoint/2010/main" val="1485210813"/>
+        <p14:creationId xmlns:p14="http://schemas.microsoft.com/office/powerpoint/2010/main" val="444640820"/>
       </p:ext>
     </p:extLst>
   </p:cSld>
@@ -9613,7 +9339,7 @@
           <p:cNvPr id="2" name="Título 1">
             <a:extLst>
               <a:ext uri="{FF2B5EF4-FFF2-40B4-BE49-F238E27FC236}">
-                <a16:creationId xmlns:a16="http://schemas.microsoft.com/office/drawing/2014/main" id="{4AB5D10E-8DEB-EF47-9499-3B7DD2CA86EB}"/>
+                <a16:creationId xmlns:a16="http://schemas.microsoft.com/office/drawing/2014/main" id="{590ECBAC-4294-66B4-5CBE-22EB381C9D44}"/>
               </a:ext>
             </a:extLst>
           </p:cNvPr>
@@ -9641,7 +9367,7 @@
           <p:cNvPr id="3" name="Marcador de contenido 2">
             <a:extLst>
               <a:ext uri="{FF2B5EF4-FFF2-40B4-BE49-F238E27FC236}">
-                <a16:creationId xmlns:a16="http://schemas.microsoft.com/office/drawing/2014/main" id="{E4E1ACF2-FBA7-F1EC-2A66-39377A3A687B}"/>
+                <a16:creationId xmlns:a16="http://schemas.microsoft.com/office/drawing/2014/main" id="{35966216-8C9C-56F0-4CC2-35B24A620542}"/>
               </a:ext>
             </a:extLst>
           </p:cNvPr>
@@ -9658,69 +9384,32 @@
           <a:lstStyle/>
           <a:p>
             <a:r>
-              <a:rPr lang="es-PE" dirty="0"/>
-              <a:t>Java 17 + Maven: estándar </a:t>
-            </a:r>
-            <a:r>
-              <a:rPr lang="es-PE" dirty="0" err="1"/>
-              <a:t>enterprise</a:t>
-            </a:r>
-            <a:r>
-              <a:rPr lang="es-PE" dirty="0"/>
-              <a:t> y CI/CD</a:t>
-            </a:r>
-          </a:p>
-          <a:p>
-            <a:r>
-              <a:rPr lang="es-PE" dirty="0"/>
-              <a:t>Karate 1.5: </a:t>
-            </a:r>
-            <a:r>
-              <a:rPr lang="es-PE" dirty="0" err="1"/>
-              <a:t>features</a:t>
-            </a:r>
-            <a:r>
-              <a:rPr lang="es-PE" dirty="0"/>
-              <a:t> legibles, reportes HTML</a:t>
-            </a:r>
-          </a:p>
-          <a:p>
-            <a:r>
-              <a:rPr lang="es-PE" dirty="0" err="1"/>
-              <a:t>grpc</a:t>
-            </a:r>
-            <a:r>
-              <a:rPr lang="es-PE" dirty="0"/>
-              <a:t>-java + </a:t>
-            </a:r>
-            <a:r>
-              <a:rPr lang="es-PE" dirty="0" err="1"/>
-              <a:t>UssdGrpcClient</a:t>
-            </a:r>
-            <a:r>
-              <a:rPr lang="es-PE" dirty="0"/>
-              <a:t>: contrato </a:t>
-            </a:r>
-            <a:r>
-              <a:rPr lang="es-PE" dirty="0" err="1"/>
-              <a:t>Protobuf</a:t>
-            </a:r>
-            <a:endParaRPr lang="es-PE" dirty="0"/>
-          </a:p>
-          <a:p>
-            <a:r>
-              <a:rPr lang="es-PE" dirty="0"/>
-              <a:t>Postman: exploración manual</a:t>
-            </a:r>
-          </a:p>
-          <a:p>
-            <a:r>
-              <a:rPr lang="es-PE" dirty="0" err="1"/>
-              <a:t>JMeter</a:t>
-            </a:r>
-            <a:r>
-              <a:rPr lang="es-PE" dirty="0"/>
-              <a:t>: recomendado fase 2 para carga</a:t>
+              <a:rPr lang="es-PE"/>
+              <a:t>Java 17 + Maven: estandar enterprise y CI/CD</a:t>
+            </a:r>
+          </a:p>
+          <a:p>
+            <a:r>
+              <a:rPr lang="es-PE"/>
+              <a:t>Karate 1.5: features legibles, reportes HTML</a:t>
+            </a:r>
+          </a:p>
+          <a:p>
+            <a:r>
+              <a:rPr lang="es-PE"/>
+              <a:t>grpc-java + UssdGrpcClient: contrato Protobuf</a:t>
+            </a:r>
+          </a:p>
+          <a:p>
+            <a:r>
+              <a:rPr lang="es-PE"/>
+              <a:t>Postman: exploracion manual</a:t>
+            </a:r>
+          </a:p>
+          <a:p>
+            <a:r>
+              <a:rPr lang="es-PE"/>
+              <a:t>JMeter: recomendado fase 2 para carga</a:t>
             </a:r>
           </a:p>
         </p:txBody>
@@ -9728,7 +9417,7 @@
     </p:spTree>
     <p:extLst>
       <p:ext uri="{BB962C8B-B14F-4D97-AF65-F5344CB8AC3E}">
-        <p14:creationId xmlns:p14="http://schemas.microsoft.com/office/powerpoint/2010/main" val="4163262125"/>
+        <p14:creationId xmlns:p14="http://schemas.microsoft.com/office/powerpoint/2010/main" val="2661540402"/>
       </p:ext>
     </p:extLst>
   </p:cSld>
@@ -9760,7 +9449,7 @@
           <p:cNvPr id="2" name="Título 1">
             <a:extLst>
               <a:ext uri="{FF2B5EF4-FFF2-40B4-BE49-F238E27FC236}">
-                <a16:creationId xmlns:a16="http://schemas.microsoft.com/office/drawing/2014/main" id="{EFC32586-28CA-B430-D620-2871ABF7B096}"/>
+                <a16:creationId xmlns:a16="http://schemas.microsoft.com/office/drawing/2014/main" id="{C8B00FE0-B803-1B48-486C-3D897C6A91BB}"/>
               </a:ext>
             </a:extLst>
           </p:cNvPr>
@@ -9788,7 +9477,7 @@
           <p:cNvPr id="3" name="Marcador de contenido 2">
             <a:extLst>
               <a:ext uri="{FF2B5EF4-FFF2-40B4-BE49-F238E27FC236}">
-                <a16:creationId xmlns:a16="http://schemas.microsoft.com/office/drawing/2014/main" id="{F12C0AFF-390B-2687-21EC-37D5D86CB7B3}"/>
+                <a16:creationId xmlns:a16="http://schemas.microsoft.com/office/drawing/2014/main" id="{BB82CF09-0658-D4A3-A353-4D8BBBAB3F05}"/>
               </a:ext>
             </a:extLst>
           </p:cNvPr>
@@ -9805,65 +9494,41 @@
           <a:lstStyle/>
           <a:p>
             <a:r>
-              <a:rPr lang="es-ES" dirty="0"/>
-              <a:t>Nivel 1 - Contrato (sin red): </a:t>
-            </a:r>
-            <a:r>
-              <a:rPr lang="es-ES" dirty="0" err="1"/>
-              <a:t>payloads</a:t>
-            </a:r>
-            <a:r>
-              <a:rPr lang="es-ES" dirty="0"/>
-              <a:t> inicial y posterior</a:t>
-            </a:r>
-          </a:p>
-          <a:p>
-            <a:r>
-              <a:rPr lang="es-ES" dirty="0"/>
-              <a:t>Nivel 2 - Integración: </a:t>
-            </a:r>
-            <a:r>
-              <a:rPr lang="es-ES" dirty="0" err="1"/>
-              <a:t>smoke</a:t>
-            </a:r>
-            <a:r>
-              <a:rPr lang="es-ES" dirty="0"/>
-              <a:t> + opciones 1 a 4</a:t>
-            </a:r>
-          </a:p>
-          <a:p>
-            <a:r>
-              <a:rPr lang="es-ES" dirty="0"/>
+              <a:rPr lang="es-ES"/>
+              <a:t>Nivel 1 - Contrato (sin red): payloads inicial y posterior</a:t>
+            </a:r>
+          </a:p>
+          <a:p>
+            <a:r>
+              <a:rPr lang="es-ES"/>
+              <a:t>Nivel 2 - Integracion: smoke + opciones 1 a 4</a:t>
+            </a:r>
+          </a:p>
+          <a:p>
+            <a:r>
+              <a:rPr lang="es-ES"/>
               <a:t>Nivel 3 - E2E: Happy Path completo</a:t>
             </a:r>
           </a:p>
           <a:p>
             <a:r>
-              <a:rPr lang="es-ES" dirty="0"/>
-              <a:t>Validar contrato y sesión antes de exploración masiva</a:t>
-            </a:r>
-          </a:p>
-          <a:p>
-            <a:r>
-              <a:rPr lang="es-ES" dirty="0"/>
-              <a:t>CI: contrato en cada </a:t>
-            </a:r>
-            <a:r>
-              <a:rPr lang="es-ES" dirty="0" err="1"/>
-              <a:t>build</a:t>
-            </a:r>
-            <a:r>
-              <a:rPr lang="es-ES" dirty="0"/>
-              <a:t>; integración si ambiente UP</a:t>
-            </a:r>
-            <a:endParaRPr lang="es-PE" dirty="0"/>
+              <a:rPr lang="es-ES"/>
+              <a:t>Validar contrato y sesion antes de exploracion masiva</a:t>
+            </a:r>
+          </a:p>
+          <a:p>
+            <a:r>
+              <a:rPr lang="es-ES"/>
+              <a:t>CI: contrato en cada build; integracion si ambiente UP</a:t>
+            </a:r>
+            <a:endParaRPr lang="es-PE"/>
           </a:p>
         </p:txBody>
       </p:sp>
     </p:spTree>
     <p:extLst>
       <p:ext uri="{BB962C8B-B14F-4D97-AF65-F5344CB8AC3E}">
-        <p14:creationId xmlns:p14="http://schemas.microsoft.com/office/powerpoint/2010/main" val="1576188214"/>
+        <p14:creationId xmlns:p14="http://schemas.microsoft.com/office/powerpoint/2010/main" val="2264851962"/>
       </p:ext>
     </p:extLst>
   </p:cSld>
@@ -9895,7 +9560,7 @@
           <p:cNvPr id="2" name="Título 1">
             <a:extLst>
               <a:ext uri="{FF2B5EF4-FFF2-40B4-BE49-F238E27FC236}">
-                <a16:creationId xmlns:a16="http://schemas.microsoft.com/office/drawing/2014/main" id="{0774FD4C-B385-9404-E002-800BB660BCFD}"/>
+                <a16:creationId xmlns:a16="http://schemas.microsoft.com/office/drawing/2014/main" id="{01762241-7ED0-6B06-EAC7-F5D660A54156}"/>
               </a:ext>
             </a:extLst>
           </p:cNvPr>
@@ -9924,7 +9589,7 @@
           <p:cNvPr id="3" name="Marcador de contenido 2">
             <a:extLst>
               <a:ext uri="{FF2B5EF4-FFF2-40B4-BE49-F238E27FC236}">
-                <a16:creationId xmlns:a16="http://schemas.microsoft.com/office/drawing/2014/main" id="{AC915ACC-F857-5626-A24E-59CBF17D0E2C}"/>
+                <a16:creationId xmlns:a16="http://schemas.microsoft.com/office/drawing/2014/main" id="{E86C7EBB-F503-081A-252E-82457ED7F11F}"/>
               </a:ext>
             </a:extLst>
           </p:cNvPr>
@@ -9941,59 +9606,47 @@
           <a:lstStyle/>
           <a:p>
             <a:r>
-              <a:rPr lang="es-ES" dirty="0"/>
-              <a:t>1. Marca *999# - menú principal (llamada inicial)</a:t>
-            </a:r>
-          </a:p>
-          <a:p>
-            <a:r>
-              <a:rPr lang="es-ES" dirty="0"/>
-              <a:t>2. Opción 1: Consultar saldo</a:t>
-            </a:r>
-          </a:p>
-          <a:p>
-            <a:r>
-              <a:rPr lang="es-ES" dirty="0"/>
-              <a:t>3. Opción 2: Recargar (monto)</a:t>
-            </a:r>
-          </a:p>
-          <a:p>
-            <a:r>
-              <a:rPr lang="es-ES" dirty="0"/>
-              <a:t>4. Opción 3: Estado de cuenta</a:t>
-            </a:r>
-          </a:p>
-          <a:p>
-            <a:r>
-              <a:rPr lang="es-ES" dirty="0"/>
-              <a:t>5. Opción 4: Salir</a:t>
-            </a:r>
-          </a:p>
-          <a:p>
-            <a:r>
-              <a:rPr lang="es-ES" dirty="0"/>
-              <a:t>Cada paso reutiliza el mismo </a:t>
-            </a:r>
-            <a:r>
-              <a:rPr lang="es-ES" dirty="0" err="1"/>
-              <a:t>sessionId</a:t>
-            </a:r>
-            <a:r>
-              <a:rPr lang="es-ES" dirty="0"/>
-              <a:t> y </a:t>
-            </a:r>
-            <a:r>
-              <a:rPr lang="es-ES" dirty="0" err="1"/>
-              <a:t>msisdn</a:t>
-            </a:r>
-            <a:endParaRPr lang="es-PE" dirty="0"/>
+              <a:rPr lang="es-ES"/>
+              <a:t>1. Marca *999# - menu principal (llamada inicial)</a:t>
+            </a:r>
+          </a:p>
+          <a:p>
+            <a:r>
+              <a:rPr lang="es-ES"/>
+              <a:t>2. Opcion 1: Consultar saldo</a:t>
+            </a:r>
+          </a:p>
+          <a:p>
+            <a:r>
+              <a:rPr lang="es-ES"/>
+              <a:t>3. Opcion 2: Recargar (monto)</a:t>
+            </a:r>
+          </a:p>
+          <a:p>
+            <a:r>
+              <a:rPr lang="es-ES"/>
+              <a:t>4. Opcion 3: Estado de cuenta</a:t>
+            </a:r>
+          </a:p>
+          <a:p>
+            <a:r>
+              <a:rPr lang="es-ES"/>
+              <a:t>5. Opcion 4: Salir</a:t>
+            </a:r>
+          </a:p>
+          <a:p>
+            <a:r>
+              <a:rPr lang="es-ES"/>
+              <a:t>Cada paso reutiliza el mismo sessionId y msisdn</a:t>
+            </a:r>
+            <a:endParaRPr lang="es-PE"/>
           </a:p>
         </p:txBody>
       </p:sp>
     </p:spTree>
     <p:extLst>
       <p:ext uri="{BB962C8B-B14F-4D97-AF65-F5344CB8AC3E}">
-        <p14:creationId xmlns:p14="http://schemas.microsoft.com/office/powerpoint/2010/main" val="787612494"/>
+        <p14:creationId xmlns:p14="http://schemas.microsoft.com/office/powerpoint/2010/main" val="1237154658"/>
       </p:ext>
     </p:extLst>
   </p:cSld>
@@ -10025,7 +9678,7 @@
           <p:cNvPr id="2" name="Título 1">
             <a:extLst>
               <a:ext uri="{FF2B5EF4-FFF2-40B4-BE49-F238E27FC236}">
-                <a16:creationId xmlns:a16="http://schemas.microsoft.com/office/drawing/2014/main" id="{97B480BD-D73A-4C5A-5E1C-BF0F6E5DF4B8}"/>
+                <a16:creationId xmlns:a16="http://schemas.microsoft.com/office/drawing/2014/main" id="{4CF0B1B2-839D-0B11-318F-326FC7B85B2B}"/>
               </a:ext>
             </a:extLst>
           </p:cNvPr>
@@ -10053,7 +9706,7 @@
           <p:cNvPr id="3" name="Marcador de contenido 2">
             <a:extLst>
               <a:ext uri="{FF2B5EF4-FFF2-40B4-BE49-F238E27FC236}">
-                <a16:creationId xmlns:a16="http://schemas.microsoft.com/office/drawing/2014/main" id="{FFE26A34-88D4-CAD8-71E6-8709C14E708D}"/>
+                <a16:creationId xmlns:a16="http://schemas.microsoft.com/office/drawing/2014/main" id="{B78CEB16-D647-50D3-BB41-A3DFD31D8A01}"/>
               </a:ext>
             </a:extLst>
           </p:cNvPr>
@@ -10097,7 +9750,7 @@
     </p:spTree>
     <p:extLst>
       <p:ext uri="{BB962C8B-B14F-4D97-AF65-F5344CB8AC3E}">
-        <p14:creationId xmlns:p14="http://schemas.microsoft.com/office/powerpoint/2010/main" val="1356208068"/>
+        <p14:creationId xmlns:p14="http://schemas.microsoft.com/office/powerpoint/2010/main" val="1298418718"/>
       </p:ext>
     </p:extLst>
   </p:cSld>
@@ -10129,7 +9782,7 @@
           <p:cNvPr id="2" name="Título 1">
             <a:extLst>
               <a:ext uri="{FF2B5EF4-FFF2-40B4-BE49-F238E27FC236}">
-                <a16:creationId xmlns:a16="http://schemas.microsoft.com/office/drawing/2014/main" id="{09F35365-F41E-B95B-29DC-76151D7F9B52}"/>
+                <a16:creationId xmlns:a16="http://schemas.microsoft.com/office/drawing/2014/main" id="{1DD89BED-94E2-CC98-7FED-C204271863F6}"/>
               </a:ext>
             </a:extLst>
           </p:cNvPr>
@@ -10157,7 +9810,7 @@
           <p:cNvPr id="3" name="Marcador de contenido 2">
             <a:extLst>
               <a:ext uri="{FF2B5EF4-FFF2-40B4-BE49-F238E27FC236}">
-                <a16:creationId xmlns:a16="http://schemas.microsoft.com/office/drawing/2014/main" id="{719B6C20-4E88-0347-1FF5-D26B4F808FCB}"/>
+                <a16:creationId xmlns:a16="http://schemas.microsoft.com/office/drawing/2014/main" id="{A505BECD-3CFB-3F17-C632-D0200D81402A}"/>
               </a:ext>
             </a:extLst>
           </p:cNvPr>
@@ -10207,7 +9860,7 @@
     </p:spTree>
     <p:extLst>
       <p:ext uri="{BB962C8B-B14F-4D97-AF65-F5344CB8AC3E}">
-        <p14:creationId xmlns:p14="http://schemas.microsoft.com/office/powerpoint/2010/main" val="4266828413"/>
+        <p14:creationId xmlns:p14="http://schemas.microsoft.com/office/powerpoint/2010/main" val="3570592344"/>
       </p:ext>
     </p:extLst>
   </p:cSld>

</xml_diff>